<commit_message>
Update presentation slides with official branding and logo
Update Dime Time presentation slides to use the official brand color (#918EF4) as a solid background and replace the cover page icon with the official Dime Time logo.

Replit-Commit-Author: Agent
Replit-Commit-Session-Id: ce089693-6854-4324-93b2-95f77a9759f4
Replit-Commit-Checkpoint-Type: full_checkpoint
Replit-Commit-Event-Id: c57e43cf-4aea-4991-b513-64c443b4c667
Replit-Commit-Screenshot-Url: https://storage.googleapis.com/screenshot-production-us-central1/ceb23eaa-0ec0-4109-a10a-5e37190a0ad7/ce089693-6854-4324-93b2-95f77a9759f4/rTEF2G1
Replit-Helium-Checkpoint-Created: true
</commit_message>
<xml_diff>
--- a/attached_assets/patent-deck-slides/dime-time-patent-deck.pptx
+++ b/attached_assets/patent-deck-slides/dime-time-patent-deck.pptx
@@ -164,7 +164,7 @@
         <p:txBody>
           <a:bodyPr/>
           <a:p>
-            <a:fld id="{7E0A409E-3D3F-49C5-B0EF-C02A6E1E6D10}" type="slidenum">
+            <a:fld id="{999CBDB0-8DED-4710-8B3E-5F543B61E63C}" type="slidenum">
               <a:t>&lt;#&gt;</a:t>
             </a:fld>
           </a:p>
@@ -247,7 +247,7 @@
         <p:txBody>
           <a:bodyPr/>
           <a:p>
-            <a:fld id="{54D6E6DB-61B0-4E36-BBC5-A933E905389A}" type="slidenum">
+            <a:fld id="{B49D883B-053D-4AF7-B540-74729137A2FC}" type="slidenum">
               <a:t>&lt;#&gt;</a:t>
             </a:fld>
           </a:p>
@@ -330,7 +330,7 @@
         <p:txBody>
           <a:bodyPr/>
           <a:p>
-            <a:fld id="{76FA81C0-B610-4CA8-87D8-CD892CBAF653}" type="slidenum">
+            <a:fld id="{22DF2635-F874-4A42-BF37-432315FA5E01}" type="slidenum">
               <a:t>&lt;#&gt;</a:t>
             </a:fld>
           </a:p>
@@ -413,7 +413,7 @@
         <p:txBody>
           <a:bodyPr/>
           <a:p>
-            <a:fld id="{31E33D8D-5BAA-4BE7-A8AA-A1894EA94281}" type="slidenum">
+            <a:fld id="{05332C2E-6D64-4886-9E01-50A89BA0DF80}" type="slidenum">
               <a:t>&lt;#&gt;</a:t>
             </a:fld>
           </a:p>
@@ -496,7 +496,7 @@
         <p:txBody>
           <a:bodyPr/>
           <a:p>
-            <a:fld id="{BA2FFA6C-225D-4EAE-B5DA-7B8B6D57398D}" type="slidenum">
+            <a:fld id="{7FFB98F8-95F8-4632-873F-6BC3F4DE64FD}" type="slidenum">
               <a:t>&lt;#&gt;</a:t>
             </a:fld>
           </a:p>
@@ -662,7 +662,7 @@
         <p:txBody>
           <a:bodyPr/>
           <a:p>
-            <a:fld id="{63DC412C-2591-4662-A67C-3D694DF5129D}" type="slidenum">
+            <a:fld id="{87F928F2-AC5A-4DAA-811F-09E8C8497764}" type="slidenum">
               <a:t>&lt;#&gt;</a:t>
             </a:fld>
           </a:p>
@@ -745,7 +745,7 @@
         <p:txBody>
           <a:bodyPr/>
           <a:p>
-            <a:fld id="{6EDC4464-4577-42F7-B11D-5C3423C3B34B}" type="slidenum">
+            <a:fld id="{BD408B56-7C03-468B-A66C-93A7BBD41971}" type="slidenum">
               <a:t>&lt;#&gt;</a:t>
             </a:fld>
           </a:p>
@@ -954,7 +954,7 @@
         <p:txBody>
           <a:bodyPr/>
           <a:p>
-            <a:fld id="{C62B5D94-0663-438D-8B79-F9E3FD05F4DF}" type="slidenum">
+            <a:fld id="{15E30117-9643-4358-A029-B61ED5444B6E}" type="slidenum">
               <a:t>&lt;#&gt;</a:t>
             </a:fld>
           </a:p>
@@ -1037,7 +1037,7 @@
         <p:txBody>
           <a:bodyPr/>
           <a:p>
-            <a:fld id="{4E0419C0-6F64-4F59-9A36-B93309528BA9}" type="slidenum">
+            <a:fld id="{BC0D7705-0FF3-437E-ADDF-8CAB7139FAE7}" type="slidenum">
               <a:t>&lt;#&gt;</a:t>
             </a:fld>
           </a:p>
@@ -1160,7 +1160,7 @@
         <p:txBody>
           <a:bodyPr/>
           <a:p>
-            <a:fld id="{DE1E8E04-E323-4E4F-B18A-047B8D7B3C67}" type="slidenum">
+            <a:fld id="{E27DA2C6-9D23-45ED-AACF-73E2A3994AAE}" type="slidenum">
               <a:t>&lt;#&gt;</a:t>
             </a:fld>
           </a:p>
@@ -1243,7 +1243,7 @@
         <p:txBody>
           <a:bodyPr/>
           <a:p>
-            <a:fld id="{C1C3D0AF-943F-44C6-A838-C7F58233443C}" type="slidenum">
+            <a:fld id="{BF5325BF-6C33-4F8B-9477-9E7B0D389596}" type="slidenum">
               <a:t>&lt;#&gt;</a:t>
             </a:fld>
           </a:p>
@@ -1531,7 +1531,7 @@
               </a:lnSpc>
               <a:buNone/>
             </a:pPr>
-            <a:fld id="{4321E941-1E02-4B19-BDA4-1E856BE280BC}" type="slidenum">
+            <a:fld id="{C94F9030-4BB9-4DC4-8167-95000641C7C1}" type="slidenum">
               <a:rPr b="0" lang="en-US" sz="1200" spc="-1" strike="noStrike">
                 <a:solidFill>
                   <a:schemeClr val="dk1">
@@ -2053,7 +2053,7 @@
               </a:lnSpc>
               <a:buNone/>
             </a:pPr>
-            <a:fld id="{A4615470-24D1-48E4-96F7-70AB7C824247}" type="slidenum">
+            <a:fld id="{E9D8A60E-9724-4917-9798-96829E061D59}" type="slidenum">
               <a:rPr b="0" lang="en-US" sz="1200" spc="-1" strike="noStrike">
                 <a:solidFill>
                   <a:schemeClr val="dk1">
@@ -2621,7 +2621,7 @@
               </a:lnSpc>
               <a:buNone/>
             </a:pPr>
-            <a:fld id="{BF820E77-E71C-4B73-BFA4-8213CB465CDE}" type="slidenum">
+            <a:fld id="{A77B8638-7C00-4E17-80DC-3BB9F95BA9D6}" type="slidenum">
               <a:rPr b="0" lang="en-US" sz="1200" spc="-1" strike="noStrike">
                 <a:solidFill>
                   <a:schemeClr val="dk1">
@@ -3085,7 +3085,7 @@
               </a:lnSpc>
               <a:buNone/>
             </a:pPr>
-            <a:fld id="{C3BFF203-F840-4605-BB40-C905AE702A7D}" type="slidenum">
+            <a:fld id="{6D73660C-5C10-4591-BCDB-BCA36A0B5226}" type="slidenum">
               <a:rPr b="0" lang="en-US" sz="1200" spc="-1" strike="noStrike">
                 <a:solidFill>
                   <a:schemeClr val="dk1">
@@ -3549,7 +3549,7 @@
               </a:lnSpc>
               <a:buNone/>
             </a:pPr>
-            <a:fld id="{83F518A7-E6C7-4BF8-8E45-7CB737A71623}" type="slidenum">
+            <a:fld id="{C7DE72C4-6A3D-4B59-9028-EE3CFF004AE7}" type="slidenum">
               <a:rPr b="0" lang="en-US" sz="1200" spc="-1" strike="noStrike">
                 <a:solidFill>
                   <a:schemeClr val="dk1">
@@ -4013,7 +4013,7 @@
               </a:lnSpc>
               <a:buNone/>
             </a:pPr>
-            <a:fld id="{1BD7E0D7-333B-4D1D-9A01-42364287580C}" type="slidenum">
+            <a:fld id="{8A8F1F7B-0B9C-4BEF-AF9A-DF35E05E03EC}" type="slidenum">
               <a:rPr b="0" lang="en-US" sz="1200" spc="-1" strike="noStrike">
                 <a:solidFill>
                   <a:schemeClr val="dk1">
@@ -4358,7 +4358,7 @@
               </a:lnSpc>
               <a:buNone/>
             </a:pPr>
-            <a:fld id="{210D8A84-3989-45ED-A1DC-AECDA488B712}" type="slidenum">
+            <a:fld id="{87E47778-8AEC-4EEE-AC13-85E469FFB8BE}" type="slidenum">
               <a:rPr b="0" lang="en-US" sz="1200" spc="-1" strike="noStrike">
                 <a:solidFill>
                   <a:schemeClr val="dk1">
@@ -5001,7 +5001,7 @@
               </a:lnSpc>
               <a:buNone/>
             </a:pPr>
-            <a:fld id="{481A544E-E4C6-4398-A1D8-A637D38E55F7}" type="slidenum">
+            <a:fld id="{16F35122-ACA8-4FDA-808F-AF6CCB445D8E}" type="slidenum">
               <a:rPr b="0" lang="en-US" sz="1200" spc="-1" strike="noStrike">
                 <a:solidFill>
                   <a:schemeClr val="dk1">
@@ -5760,7 +5760,7 @@
               </a:lnSpc>
               <a:buNone/>
             </a:pPr>
-            <a:fld id="{5A3C209A-116D-4A4A-858D-3E2BF5A8BD77}" type="slidenum">
+            <a:fld id="{BDA3600A-67E7-479A-A290-CB49CE644EE6}" type="slidenum">
               <a:rPr b="0" lang="en-US" sz="1200" spc="-1" strike="noStrike">
                 <a:solidFill>
                   <a:schemeClr val="dk1">
@@ -6045,7 +6045,7 @@
               </a:lnSpc>
               <a:buNone/>
             </a:pPr>
-            <a:fld id="{60F44F84-AA28-4376-80B3-9B0E9C320670}" type="slidenum">
+            <a:fld id="{6295DC24-E164-4CAC-ACEE-8FA97388F827}" type="slidenum">
               <a:rPr b="0" lang="en-US" sz="1200" spc="-1" strike="noStrike">
                 <a:solidFill>
                   <a:schemeClr val="dk1">
@@ -6278,7 +6278,7 @@
               </a:lnSpc>
               <a:buNone/>
             </a:pPr>
-            <a:fld id="{5F732A04-9C74-410A-B3C8-E69D3452540B}" type="slidenum">
+            <a:fld id="{33A07C7E-EFEF-45C4-82F3-753B7376E41D}" type="slidenum">
               <a:rPr b="0" lang="en-US" sz="1200" spc="-1" strike="noStrike">
                 <a:solidFill>
                   <a:schemeClr val="dk1">
@@ -6586,17 +6586,9 @@
   <p:cSld>
     <p:bg>
       <p:bgPr>
-        <a:gradFill rotWithShape="0">
-          <a:gsLst>
-            <a:gs pos="0">
-              <a:srgbClr val="918ef4"/>
-            </a:gs>
-            <a:gs pos="100000">
-              <a:srgbClr val="6f6cd9"/>
-            </a:gs>
-          </a:gsLst>
-          <a:lin ang="2700000"/>
-        </a:gradFill>
+        <a:solidFill>
+          <a:srgbClr val="918ef4"/>
+        </a:solidFill>
       </p:bgPr>
     </p:bg>
     <p:spTree>
@@ -6613,26 +6605,154 @@
           <a:chExt cx="0" cy="0"/>
         </a:xfrm>
       </p:grpSpPr>
-      <p:sp>
-        <p:nvSpPr>
-          <p:cNvPr id="67" name="Oval 1"/>
-          <p:cNvSpPr/>
-          <p:nvPr/>
-        </p:nvSpPr>
-        <p:spPr>
-          <a:xfrm>
-            <a:off x="5684400" y="1828800"/>
-            <a:ext cx="822600" cy="822600"/>
-          </a:xfrm>
-          <a:prstGeom prst="ellipse">
-            <a:avLst/>
-          </a:prstGeom>
-          <a:noFill/>
-          <a:ln w="38100">
-            <a:solidFill>
-              <a:srgbClr val="ffffff"/>
-            </a:solidFill>
-            <a:round/>
+      <p:pic>
+        <p:nvPicPr>
+          <p:cNvPr id="67" name="Picture 1" descr="_logo_transparent.png"/>
+          <p:cNvPicPr/>
+          <p:nvPr/>
+        </p:nvPicPr>
+        <p:blipFill>
+          <a:blip r:embed="rId1"/>
+          <a:stretch/>
+        </p:blipFill>
+        <p:spPr>
+          <a:xfrm>
+            <a:off x="4998600" y="1280160"/>
+            <a:ext cx="2194200" cy="2194200"/>
+          </a:xfrm>
+          <a:prstGeom prst="rect">
+            <a:avLst/>
+          </a:prstGeom>
+          <a:ln w="0">
+            <a:noFill/>
+          </a:ln>
+        </p:spPr>
+      </p:pic>
+      <p:sp>
+        <p:nvSpPr>
+          <p:cNvPr id="68" name="TextBox 2"/>
+          <p:cNvSpPr/>
+          <p:nvPr/>
+        </p:nvSpPr>
+        <p:spPr>
+          <a:xfrm>
+            <a:off x="0" y="3657600"/>
+            <a:ext cx="12191400" cy="1096920"/>
+          </a:xfrm>
+          <a:prstGeom prst="rect">
+            <a:avLst/>
+          </a:prstGeom>
+          <a:noFill/>
+          <a:ln w="0">
+            <a:noFill/>
+          </a:ln>
+        </p:spPr>
+        <p:style>
+          <a:lnRef idx="0"/>
+          <a:fillRef idx="0"/>
+          <a:effectRef idx="0"/>
+          <a:fontRef idx="minor"/>
+        </p:style>
+        <p:txBody>
+          <a:bodyPr lIns="0" rIns="0" tIns="0" bIns="0" anchor="t">
+            <a:spAutoFit/>
+          </a:bodyPr>
+          <a:p>
+            <a:pPr algn="ctr" defTabSz="457200">
+              <a:lnSpc>
+                <a:spcPct val="100000"/>
+              </a:lnSpc>
+            </a:pPr>
+            <a:r>
+              <a:rPr b="1" lang="en-US" sz="7200" spc="398" strike="noStrike">
+                <a:solidFill>
+                  <a:srgbClr val="ffffff"/>
+                </a:solidFill>
+                <a:latin typeface="Inter"/>
+              </a:rPr>
+              <a:t>DIME TIME</a:t>
+            </a:r>
+            <a:endParaRPr b="0" lang="en-US" sz="7200" spc="-1" strike="noStrike">
+              <a:solidFill>
+                <a:srgbClr val="000000"/>
+              </a:solidFill>
+              <a:latin typeface="DejaVu Sans"/>
+            </a:endParaRPr>
+          </a:p>
+        </p:txBody>
+      </p:sp>
+      <p:sp>
+        <p:nvSpPr>
+          <p:cNvPr id="69" name="TextBox 3"/>
+          <p:cNvSpPr/>
+          <p:nvPr/>
+        </p:nvSpPr>
+        <p:spPr>
+          <a:xfrm>
+            <a:off x="0" y="4709160"/>
+            <a:ext cx="12191400" cy="274680"/>
+          </a:xfrm>
+          <a:prstGeom prst="rect">
+            <a:avLst/>
+          </a:prstGeom>
+          <a:noFill/>
+          <a:ln w="0">
+            <a:noFill/>
+          </a:ln>
+        </p:spPr>
+        <p:style>
+          <a:lnRef idx="0"/>
+          <a:fillRef idx="0"/>
+          <a:effectRef idx="0"/>
+          <a:fontRef idx="minor"/>
+        </p:style>
+        <p:txBody>
+          <a:bodyPr lIns="0" rIns="0" tIns="0" bIns="0" anchor="t">
+            <a:spAutoFit/>
+          </a:bodyPr>
+          <a:p>
+            <a:pPr algn="ctr" defTabSz="457200">
+              <a:lnSpc>
+                <a:spcPct val="100000"/>
+              </a:lnSpc>
+            </a:pPr>
+            <a:r>
+              <a:rPr b="1" lang="en-US" sz="1800" spc="599" strike="noStrike">
+                <a:solidFill>
+                  <a:srgbClr val="ffffff"/>
+                </a:solidFill>
+                <a:latin typeface="Inter"/>
+              </a:rPr>
+              <a:t>PATENT OVERVIEW</a:t>
+            </a:r>
+            <a:endParaRPr b="0" lang="en-US" sz="1800" spc="-1" strike="noStrike">
+              <a:solidFill>
+                <a:srgbClr val="000000"/>
+              </a:solidFill>
+              <a:latin typeface="DejaVu Sans"/>
+            </a:endParaRPr>
+          </a:p>
+        </p:txBody>
+      </p:sp>
+      <p:sp>
+        <p:nvSpPr>
+          <p:cNvPr id="70" name="Rectangle 4"/>
+          <p:cNvSpPr/>
+          <p:nvPr/>
+        </p:nvSpPr>
+        <p:spPr>
+          <a:xfrm>
+            <a:off x="4937760" y="5349240"/>
+            <a:ext cx="2285640" cy="12240"/>
+          </a:xfrm>
+          <a:prstGeom prst="rect">
+            <a:avLst/>
+          </a:prstGeom>
+          <a:solidFill>
+            <a:srgbClr val="e6e5fa"/>
+          </a:solidFill>
+          <a:ln>
+            <a:noFill/>
           </a:ln>
           <a:effectLst>
             <a:outerShdw blurRad="39960" dir="5400000" dist="23040" rotWithShape="0">
@@ -6655,7 +6775,7 @@
           <a:fontRef idx="minor"/>
         </p:style>
         <p:txBody>
-          <a:bodyPr lIns="90000" rIns="90000" tIns="45000" bIns="45000" anchor="ctr">
+          <a:bodyPr lIns="90000" rIns="90000" tIns="-32400" bIns="-32400" anchor="ctr">
             <a:noAutofit/>
           </a:bodyPr>
           <a:p>
@@ -6675,14 +6795,14 @@
       </p:sp>
       <p:sp>
         <p:nvSpPr>
-          <p:cNvPr id="68" name="TextBox 2"/>
-          <p:cNvSpPr/>
-          <p:nvPr/>
-        </p:nvSpPr>
-        <p:spPr>
-          <a:xfrm>
-            <a:off x="5684400" y="1965240"/>
-            <a:ext cx="822600" cy="549360"/>
+          <p:cNvPr id="71" name="TextBox 5"/>
+          <p:cNvSpPr/>
+          <p:nvPr/>
+        </p:nvSpPr>
+        <p:spPr>
+          <a:xfrm>
+            <a:off x="0" y="5486400"/>
+            <a:ext cx="12191400" cy="228960"/>
           </a:xfrm>
           <a:prstGeom prst="rect">
             <a:avLst/>
@@ -6699,7 +6819,7 @@
           <a:fontRef idx="minor"/>
         </p:style>
         <p:txBody>
-          <a:bodyPr lIns="0" rIns="0" tIns="0" bIns="0" anchor="ctr">
+          <a:bodyPr lIns="0" rIns="0" tIns="0" bIns="0" anchor="t">
             <a:spAutoFit/>
           </a:bodyPr>
           <a:p>
@@ -6709,15 +6829,15 @@
               </a:lnSpc>
             </a:pPr>
             <a:r>
-              <a:rPr b="1" lang="en-US" sz="3600" spc="-1" strike="noStrike">
-                <a:solidFill>
-                  <a:srgbClr val="ffffff"/>
+              <a:rPr b="0" lang="en-US" sz="1500" spc="-1" strike="noStrike">
+                <a:solidFill>
+                  <a:srgbClr val="e6e5fa"/>
                 </a:solidFill>
                 <a:latin typeface="Inter"/>
               </a:rPr>
-              <a:t>$</a:t>
-            </a:r>
-            <a:endParaRPr b="0" lang="en-US" sz="3600" spc="-1" strike="noStrike">
+              <a:t>Investor summary of the Dime Time provisional patent.</a:t>
+            </a:r>
+            <a:endParaRPr b="0" lang="en-US" sz="1500" spc="-1" strike="noStrike">
               <a:solidFill>
                 <a:srgbClr val="000000"/>
               </a:solidFill>
@@ -6728,132 +6848,14 @@
       </p:sp>
       <p:sp>
         <p:nvSpPr>
-          <p:cNvPr id="69" name="Oval 3"/>
-          <p:cNvSpPr/>
-          <p:nvPr/>
-        </p:nvSpPr>
-        <p:spPr>
-          <a:xfrm>
-            <a:off x="5565600" y="1664280"/>
-            <a:ext cx="164160" cy="164160"/>
-          </a:xfrm>
-          <a:prstGeom prst="ellipse">
-            <a:avLst/>
-          </a:prstGeom>
-          <a:solidFill>
-            <a:srgbClr val="ffffff"/>
-          </a:solidFill>
-          <a:ln>
-            <a:noFill/>
-          </a:ln>
-          <a:effectLst>
-            <a:outerShdw blurRad="39960" dir="5400000" dist="23040" rotWithShape="0">
-              <a:srgbClr val="000000">
-                <a:alpha val="35000"/>
-              </a:srgbClr>
-            </a:outerShdw>
-          </a:effectLst>
-        </p:spPr>
-        <p:style>
-          <a:lnRef idx="1">
-            <a:schemeClr val="accent1"/>
-          </a:lnRef>
-          <a:fillRef idx="3">
-            <a:schemeClr val="accent1"/>
-          </a:fillRef>
-          <a:effectRef idx="2">
-            <a:schemeClr val="accent1"/>
-          </a:effectRef>
-          <a:fontRef idx="minor"/>
-        </p:style>
-        <p:txBody>
-          <a:bodyPr lIns="90000" rIns="90000" tIns="45000" bIns="45000" anchor="ctr">
-            <a:noAutofit/>
-          </a:bodyPr>
-          <a:p>
-            <a:pPr algn="ctr" defTabSz="457200">
-              <a:lnSpc>
-                <a:spcPct val="100000"/>
-              </a:lnSpc>
-            </a:pPr>
-            <a:endParaRPr b="0" lang="en-US" sz="1800" spc="-1" strike="noStrike">
-              <a:solidFill>
-                <a:schemeClr val="lt1"/>
-              </a:solidFill>
-              <a:latin typeface="Calibri"/>
-            </a:endParaRPr>
-          </a:p>
-        </p:txBody>
-      </p:sp>
-      <p:sp>
-        <p:nvSpPr>
-          <p:cNvPr id="70" name="Oval 4"/>
-          <p:cNvSpPr/>
-          <p:nvPr/>
-        </p:nvSpPr>
-        <p:spPr>
-          <a:xfrm>
-            <a:off x="5894640" y="1664280"/>
-            <a:ext cx="164160" cy="164160"/>
-          </a:xfrm>
-          <a:prstGeom prst="ellipse">
-            <a:avLst/>
-          </a:prstGeom>
-          <a:solidFill>
-            <a:srgbClr val="ffffff"/>
-          </a:solidFill>
-          <a:ln>
-            <a:noFill/>
-          </a:ln>
-          <a:effectLst>
-            <a:outerShdw blurRad="39960" dir="5400000" dist="23040" rotWithShape="0">
-              <a:srgbClr val="000000">
-                <a:alpha val="35000"/>
-              </a:srgbClr>
-            </a:outerShdw>
-          </a:effectLst>
-        </p:spPr>
-        <p:style>
-          <a:lnRef idx="1">
-            <a:schemeClr val="accent1"/>
-          </a:lnRef>
-          <a:fillRef idx="3">
-            <a:schemeClr val="accent1"/>
-          </a:fillRef>
-          <a:effectRef idx="2">
-            <a:schemeClr val="accent1"/>
-          </a:effectRef>
-          <a:fontRef idx="minor"/>
-        </p:style>
-        <p:txBody>
-          <a:bodyPr lIns="90000" rIns="90000" tIns="45000" bIns="45000" anchor="ctr">
-            <a:noAutofit/>
-          </a:bodyPr>
-          <a:p>
-            <a:pPr algn="ctr" defTabSz="457200">
-              <a:lnSpc>
-                <a:spcPct val="100000"/>
-              </a:lnSpc>
-            </a:pPr>
-            <a:endParaRPr b="0" lang="en-US" sz="1800" spc="-1" strike="noStrike">
-              <a:solidFill>
-                <a:schemeClr val="lt1"/>
-              </a:solidFill>
-              <a:latin typeface="Calibri"/>
-            </a:endParaRPr>
-          </a:p>
-        </p:txBody>
-      </p:sp>
-      <p:sp>
-        <p:nvSpPr>
-          <p:cNvPr id="71" name="TextBox 5"/>
-          <p:cNvSpPr/>
-          <p:nvPr/>
-        </p:nvSpPr>
-        <p:spPr>
-          <a:xfrm>
-            <a:off x="0" y="2834640"/>
-            <a:ext cx="12191400" cy="1096920"/>
+          <p:cNvPr id="72" name="TextBox 6"/>
+          <p:cNvSpPr/>
+          <p:nvPr/>
+        </p:nvSpPr>
+        <p:spPr>
+          <a:xfrm>
+            <a:off x="0" y="5989320"/>
+            <a:ext cx="12191400" cy="198720"/>
           </a:xfrm>
           <a:prstGeom prst="rect">
             <a:avLst/>
@@ -6880,15 +6882,15 @@
               </a:lnSpc>
             </a:pPr>
             <a:r>
-              <a:rPr b="1" lang="en-US" sz="7200" spc="398" strike="noStrike">
+              <a:rPr b="1" lang="en-US" sz="1300" spc="-1" strike="noStrike">
                 <a:solidFill>
                   <a:srgbClr val="ffffff"/>
                 </a:solidFill>
                 <a:latin typeface="Inter"/>
               </a:rPr>
-              <a:t>DIME TIME</a:t>
-            </a:r>
-            <a:endParaRPr b="0" lang="en-US" sz="7200" spc="-1" strike="noStrike">
+              <a:t>Tim Carlisle  ·  Founder &amp; CEO</a:t>
+            </a:r>
+            <a:endParaRPr b="0" lang="en-US" sz="1300" spc="-1" strike="noStrike">
               <a:solidFill>
                 <a:srgbClr val="000000"/>
               </a:solidFill>
@@ -6899,231 +6901,13 @@
       </p:sp>
       <p:sp>
         <p:nvSpPr>
-          <p:cNvPr id="72" name="TextBox 6"/>
-          <p:cNvSpPr/>
-          <p:nvPr/>
-        </p:nvSpPr>
-        <p:spPr>
-          <a:xfrm>
-            <a:off x="0" y="4023360"/>
-            <a:ext cx="12191400" cy="274680"/>
-          </a:xfrm>
-          <a:prstGeom prst="rect">
-            <a:avLst/>
-          </a:prstGeom>
-          <a:noFill/>
-          <a:ln w="0">
-            <a:noFill/>
-          </a:ln>
-        </p:spPr>
-        <p:style>
-          <a:lnRef idx="0"/>
-          <a:fillRef idx="0"/>
-          <a:effectRef idx="0"/>
-          <a:fontRef idx="minor"/>
-        </p:style>
-        <p:txBody>
-          <a:bodyPr lIns="0" rIns="0" tIns="0" bIns="0" anchor="t">
-            <a:spAutoFit/>
-          </a:bodyPr>
-          <a:p>
-            <a:pPr algn="ctr" defTabSz="457200">
-              <a:lnSpc>
-                <a:spcPct val="100000"/>
-              </a:lnSpc>
-            </a:pPr>
-            <a:r>
-              <a:rPr b="1" lang="en-US" sz="1800" spc="599" strike="noStrike">
-                <a:solidFill>
-                  <a:srgbClr val="ffffff"/>
-                </a:solidFill>
-                <a:latin typeface="Inter"/>
-              </a:rPr>
-              <a:t>PATENT OVERVIEW</a:t>
-            </a:r>
-            <a:endParaRPr b="0" lang="en-US" sz="1800" spc="-1" strike="noStrike">
-              <a:solidFill>
-                <a:srgbClr val="000000"/>
-              </a:solidFill>
-              <a:latin typeface="DejaVu Sans"/>
-            </a:endParaRPr>
-          </a:p>
-        </p:txBody>
-      </p:sp>
-      <p:sp>
-        <p:nvSpPr>
-          <p:cNvPr id="73" name="Rectangle 7"/>
-          <p:cNvSpPr/>
-          <p:nvPr/>
-        </p:nvSpPr>
-        <p:spPr>
-          <a:xfrm>
-            <a:off x="4937760" y="4846320"/>
-            <a:ext cx="2285640" cy="12240"/>
-          </a:xfrm>
-          <a:prstGeom prst="rect">
-            <a:avLst/>
-          </a:prstGeom>
-          <a:solidFill>
-            <a:srgbClr val="e6e5fa"/>
-          </a:solidFill>
-          <a:ln>
-            <a:noFill/>
-          </a:ln>
-          <a:effectLst>
-            <a:outerShdw blurRad="39960" dir="5400000" dist="23040" rotWithShape="0">
-              <a:srgbClr val="000000">
-                <a:alpha val="35000"/>
-              </a:srgbClr>
-            </a:outerShdw>
-          </a:effectLst>
-        </p:spPr>
-        <p:style>
-          <a:lnRef idx="1">
-            <a:schemeClr val="accent1"/>
-          </a:lnRef>
-          <a:fillRef idx="3">
-            <a:schemeClr val="accent1"/>
-          </a:fillRef>
-          <a:effectRef idx="2">
-            <a:schemeClr val="accent1"/>
-          </a:effectRef>
-          <a:fontRef idx="minor"/>
-        </p:style>
-        <p:txBody>
-          <a:bodyPr lIns="90000" rIns="90000" tIns="-32400" bIns="-32400" anchor="ctr">
-            <a:noAutofit/>
-          </a:bodyPr>
-          <a:p>
-            <a:pPr algn="ctr" defTabSz="457200">
-              <a:lnSpc>
-                <a:spcPct val="100000"/>
-              </a:lnSpc>
-            </a:pPr>
-            <a:endParaRPr b="0" lang="en-US" sz="1800" spc="-1" strike="noStrike">
-              <a:solidFill>
-                <a:schemeClr val="lt1"/>
-              </a:solidFill>
-              <a:latin typeface="Calibri"/>
-            </a:endParaRPr>
-          </a:p>
-        </p:txBody>
-      </p:sp>
-      <p:sp>
-        <p:nvSpPr>
-          <p:cNvPr id="74" name="TextBox 8"/>
-          <p:cNvSpPr/>
-          <p:nvPr/>
-        </p:nvSpPr>
-        <p:spPr>
-          <a:xfrm>
-            <a:off x="0" y="5029200"/>
-            <a:ext cx="12191400" cy="228960"/>
-          </a:xfrm>
-          <a:prstGeom prst="rect">
-            <a:avLst/>
-          </a:prstGeom>
-          <a:noFill/>
-          <a:ln w="0">
-            <a:noFill/>
-          </a:ln>
-        </p:spPr>
-        <p:style>
-          <a:lnRef idx="0"/>
-          <a:fillRef idx="0"/>
-          <a:effectRef idx="0"/>
-          <a:fontRef idx="minor"/>
-        </p:style>
-        <p:txBody>
-          <a:bodyPr lIns="0" rIns="0" tIns="0" bIns="0" anchor="t">
-            <a:spAutoFit/>
-          </a:bodyPr>
-          <a:p>
-            <a:pPr algn="ctr" defTabSz="457200">
-              <a:lnSpc>
-                <a:spcPct val="100000"/>
-              </a:lnSpc>
-            </a:pPr>
-            <a:r>
-              <a:rPr b="0" lang="en-US" sz="1500" spc="-1" strike="noStrike">
-                <a:solidFill>
-                  <a:srgbClr val="e6e5fa"/>
-                </a:solidFill>
-                <a:latin typeface="Inter"/>
-              </a:rPr>
-              <a:t>Investor summary of the Dime Time provisional patent.</a:t>
-            </a:r>
-            <a:endParaRPr b="0" lang="en-US" sz="1500" spc="-1" strike="noStrike">
-              <a:solidFill>
-                <a:srgbClr val="000000"/>
-              </a:solidFill>
-              <a:latin typeface="DejaVu Sans"/>
-            </a:endParaRPr>
-          </a:p>
-        </p:txBody>
-      </p:sp>
-      <p:sp>
-        <p:nvSpPr>
-          <p:cNvPr id="75" name="TextBox 9"/>
-          <p:cNvSpPr/>
-          <p:nvPr/>
-        </p:nvSpPr>
-        <p:spPr>
-          <a:xfrm>
-            <a:off x="0" y="5669280"/>
-            <a:ext cx="12191400" cy="198720"/>
-          </a:xfrm>
-          <a:prstGeom prst="rect">
-            <a:avLst/>
-          </a:prstGeom>
-          <a:noFill/>
-          <a:ln w="0">
-            <a:noFill/>
-          </a:ln>
-        </p:spPr>
-        <p:style>
-          <a:lnRef idx="0"/>
-          <a:fillRef idx="0"/>
-          <a:effectRef idx="0"/>
-          <a:fontRef idx="minor"/>
-        </p:style>
-        <p:txBody>
-          <a:bodyPr lIns="0" rIns="0" tIns="0" bIns="0" anchor="t">
-            <a:spAutoFit/>
-          </a:bodyPr>
-          <a:p>
-            <a:pPr algn="ctr" defTabSz="457200">
-              <a:lnSpc>
-                <a:spcPct val="100000"/>
-              </a:lnSpc>
-            </a:pPr>
-            <a:r>
-              <a:rPr b="1" lang="en-US" sz="1300" spc="-1" strike="noStrike">
-                <a:solidFill>
-                  <a:srgbClr val="ffffff"/>
-                </a:solidFill>
-                <a:latin typeface="Inter"/>
-              </a:rPr>
-              <a:t>Tim Carlisle  ·  Founder &amp; CEO</a:t>
-            </a:r>
-            <a:endParaRPr b="0" lang="en-US" sz="1300" spc="-1" strike="noStrike">
-              <a:solidFill>
-                <a:srgbClr val="000000"/>
-              </a:solidFill>
-              <a:latin typeface="DejaVu Sans"/>
-            </a:endParaRPr>
-          </a:p>
-        </p:txBody>
-      </p:sp>
-      <p:sp>
-        <p:nvSpPr>
-          <p:cNvPr id="76" name="TextBox 10"/>
-          <p:cNvSpPr/>
-          <p:nvPr/>
-        </p:nvSpPr>
-        <p:spPr>
-          <a:xfrm>
-            <a:off x="0" y="5989320"/>
+          <p:cNvPr id="73" name="TextBox 7"/>
+          <p:cNvSpPr/>
+          <p:nvPr/>
+        </p:nvSpPr>
+        <p:spPr>
+          <a:xfrm>
+            <a:off x="0" y="6327720"/>
             <a:ext cx="12191400" cy="168120"/>
           </a:xfrm>
           <a:prstGeom prst="rect">
@@ -7186,17 +6970,9 @@
   <p:cSld>
     <p:bg>
       <p:bgPr>
-        <a:gradFill rotWithShape="0">
-          <a:gsLst>
-            <a:gs pos="0">
-              <a:srgbClr val="918ef4"/>
-            </a:gs>
-            <a:gs pos="100000">
-              <a:srgbClr val="6f6cd9"/>
-            </a:gs>
-          </a:gsLst>
-          <a:lin ang="2700000"/>
-        </a:gradFill>
+        <a:solidFill>
+          <a:srgbClr val="918ef4"/>
+        </a:solidFill>
       </p:bgPr>
     </p:bg>
     <p:spTree>
@@ -7215,7 +6991,7 @@
       </p:grpSpPr>
       <p:sp>
         <p:nvSpPr>
-          <p:cNvPr id="254" name="TextBox 1"/>
+          <p:cNvPr id="251" name="TextBox 1"/>
           <p:cNvSpPr/>
           <p:nvPr/>
         </p:nvSpPr>
@@ -7268,7 +7044,7 @@
       </p:sp>
       <p:sp>
         <p:nvSpPr>
-          <p:cNvPr id="255" name="TextBox 2"/>
+          <p:cNvPr id="252" name="TextBox 2"/>
           <p:cNvSpPr/>
           <p:nvPr/>
         </p:nvSpPr>
@@ -7321,7 +7097,7 @@
       </p:sp>
       <p:sp>
         <p:nvSpPr>
-          <p:cNvPr id="256" name="TextBox 3"/>
+          <p:cNvPr id="253" name="TextBox 3"/>
           <p:cNvSpPr/>
           <p:nvPr/>
         </p:nvSpPr>
@@ -7374,7 +7150,7 @@
       </p:sp>
       <p:sp>
         <p:nvSpPr>
-          <p:cNvPr id="257" name="TextBox 4"/>
+          <p:cNvPr id="254" name="TextBox 4"/>
           <p:cNvSpPr/>
           <p:nvPr/>
         </p:nvSpPr>
@@ -7427,7 +7203,7 @@
       </p:sp>
       <p:sp>
         <p:nvSpPr>
-          <p:cNvPr id="258" name="TextBox 5"/>
+          <p:cNvPr id="255" name="TextBox 5"/>
           <p:cNvSpPr/>
           <p:nvPr/>
         </p:nvSpPr>
@@ -7480,7 +7256,7 @@
       </p:sp>
       <p:sp>
         <p:nvSpPr>
-          <p:cNvPr id="259" name="TextBox 6"/>
+          <p:cNvPr id="256" name="TextBox 6"/>
           <p:cNvSpPr/>
           <p:nvPr/>
         </p:nvSpPr>
@@ -7533,7 +7309,7 @@
       </p:sp>
       <p:sp>
         <p:nvSpPr>
-          <p:cNvPr id="260" name="Rounded Rectangle 7"/>
+          <p:cNvPr id="257" name="Rounded Rectangle 7"/>
           <p:cNvSpPr/>
           <p:nvPr/>
         </p:nvSpPr>
@@ -7596,7 +7372,7 @@
       </p:sp>
       <p:sp>
         <p:nvSpPr>
-          <p:cNvPr id="261" name="Oval 8"/>
+          <p:cNvPr id="258" name="Oval 8"/>
           <p:cNvSpPr/>
           <p:nvPr/>
         </p:nvSpPr>
@@ -7655,7 +7431,7 @@
       </p:sp>
       <p:sp>
         <p:nvSpPr>
-          <p:cNvPr id="262" name="TextBox 9"/>
+          <p:cNvPr id="259" name="TextBox 9"/>
           <p:cNvSpPr/>
           <p:nvPr/>
         </p:nvSpPr>
@@ -7708,7 +7484,7 @@
       </p:sp>
       <p:sp>
         <p:nvSpPr>
-          <p:cNvPr id="263" name="TextBox 10"/>
+          <p:cNvPr id="260" name="TextBox 10"/>
           <p:cNvSpPr/>
           <p:nvPr/>
         </p:nvSpPr>
@@ -7761,7 +7537,7 @@
       </p:sp>
       <p:sp>
         <p:nvSpPr>
-          <p:cNvPr id="264" name="Rounded Rectangle 11"/>
+          <p:cNvPr id="261" name="Rounded Rectangle 11"/>
           <p:cNvSpPr/>
           <p:nvPr/>
         </p:nvSpPr>
@@ -7824,7 +7600,7 @@
       </p:sp>
       <p:sp>
         <p:nvSpPr>
-          <p:cNvPr id="265" name="Oval 12"/>
+          <p:cNvPr id="262" name="Oval 12"/>
           <p:cNvSpPr/>
           <p:nvPr/>
         </p:nvSpPr>
@@ -7883,7 +7659,7 @@
       </p:sp>
       <p:sp>
         <p:nvSpPr>
-          <p:cNvPr id="266" name="TextBox 13"/>
+          <p:cNvPr id="263" name="TextBox 13"/>
           <p:cNvSpPr/>
           <p:nvPr/>
         </p:nvSpPr>
@@ -7936,7 +7712,7 @@
       </p:sp>
       <p:sp>
         <p:nvSpPr>
-          <p:cNvPr id="267" name="TextBox 14"/>
+          <p:cNvPr id="264" name="TextBox 14"/>
           <p:cNvSpPr/>
           <p:nvPr/>
         </p:nvSpPr>
@@ -7989,7 +7765,7 @@
       </p:sp>
       <p:sp>
         <p:nvSpPr>
-          <p:cNvPr id="268" name="Rounded Rectangle 15"/>
+          <p:cNvPr id="265" name="Rounded Rectangle 15"/>
           <p:cNvSpPr/>
           <p:nvPr/>
         </p:nvSpPr>
@@ -8052,7 +7828,7 @@
       </p:sp>
       <p:sp>
         <p:nvSpPr>
-          <p:cNvPr id="269" name="Oval 16"/>
+          <p:cNvPr id="266" name="Oval 16"/>
           <p:cNvSpPr/>
           <p:nvPr/>
         </p:nvSpPr>
@@ -8111,7 +7887,7 @@
       </p:sp>
       <p:sp>
         <p:nvSpPr>
-          <p:cNvPr id="270" name="TextBox 17"/>
+          <p:cNvPr id="267" name="TextBox 17"/>
           <p:cNvSpPr/>
           <p:nvPr/>
         </p:nvSpPr>
@@ -8164,7 +7940,7 @@
       </p:sp>
       <p:sp>
         <p:nvSpPr>
-          <p:cNvPr id="271" name="TextBox 18"/>
+          <p:cNvPr id="268" name="TextBox 18"/>
           <p:cNvSpPr/>
           <p:nvPr/>
         </p:nvSpPr>
@@ -8217,7 +7993,7 @@
       </p:sp>
       <p:sp>
         <p:nvSpPr>
-          <p:cNvPr id="272" name="Rounded Rectangle 19"/>
+          <p:cNvPr id="269" name="Rounded Rectangle 19"/>
           <p:cNvSpPr/>
           <p:nvPr/>
         </p:nvSpPr>
@@ -8280,7 +8056,7 @@
       </p:sp>
       <p:sp>
         <p:nvSpPr>
-          <p:cNvPr id="273" name="Oval 20"/>
+          <p:cNvPr id="270" name="Oval 20"/>
           <p:cNvSpPr/>
           <p:nvPr/>
         </p:nvSpPr>
@@ -8339,7 +8115,7 @@
       </p:sp>
       <p:sp>
         <p:nvSpPr>
-          <p:cNvPr id="274" name="TextBox 21"/>
+          <p:cNvPr id="271" name="TextBox 21"/>
           <p:cNvSpPr/>
           <p:nvPr/>
         </p:nvSpPr>
@@ -8392,7 +8168,7 @@
       </p:sp>
       <p:sp>
         <p:nvSpPr>
-          <p:cNvPr id="275" name="Rectangle 22"/>
+          <p:cNvPr id="272" name="Rectangle 22"/>
           <p:cNvSpPr/>
           <p:nvPr/>
         </p:nvSpPr>
@@ -8451,7 +8227,7 @@
       </p:sp>
       <p:sp>
         <p:nvSpPr>
-          <p:cNvPr id="276" name="TextBox 23"/>
+          <p:cNvPr id="273" name="TextBox 23"/>
           <p:cNvSpPr/>
           <p:nvPr/>
         </p:nvSpPr>
@@ -8504,7 +8280,7 @@
       </p:sp>
       <p:sp>
         <p:nvSpPr>
-          <p:cNvPr id="277" name="TextBox 24"/>
+          <p:cNvPr id="274" name="TextBox 24"/>
           <p:cNvSpPr/>
           <p:nvPr/>
         </p:nvSpPr>
@@ -8557,7 +8333,7 @@
       </p:sp>
       <p:sp>
         <p:nvSpPr>
-          <p:cNvPr id="278" name="TextBox 25"/>
+          <p:cNvPr id="275" name="TextBox 25"/>
           <p:cNvSpPr/>
           <p:nvPr/>
         </p:nvSpPr>
@@ -8626,17 +8402,9 @@
   <p:cSld>
     <p:bg>
       <p:bgPr>
-        <a:gradFill rotWithShape="0">
-          <a:gsLst>
-            <a:gs pos="0">
-              <a:srgbClr val="918ef4"/>
-            </a:gs>
-            <a:gs pos="100000">
-              <a:srgbClr val="6f6cd9"/>
-            </a:gs>
-          </a:gsLst>
-          <a:lin ang="2700000"/>
-        </a:gradFill>
+        <a:solidFill>
+          <a:srgbClr val="918ef4"/>
+        </a:solidFill>
       </p:bgPr>
     </p:bg>
     <p:spTree>
@@ -8655,7 +8423,7 @@
       </p:grpSpPr>
       <p:sp>
         <p:nvSpPr>
-          <p:cNvPr id="279" name="TextBox 1"/>
+          <p:cNvPr id="276" name="TextBox 1"/>
           <p:cNvSpPr/>
           <p:nvPr/>
         </p:nvSpPr>
@@ -8708,7 +8476,7 @@
       </p:sp>
       <p:sp>
         <p:nvSpPr>
-          <p:cNvPr id="280" name="TextBox 2"/>
+          <p:cNvPr id="277" name="TextBox 2"/>
           <p:cNvSpPr/>
           <p:nvPr/>
         </p:nvSpPr>
@@ -8761,7 +8529,7 @@
       </p:sp>
       <p:sp>
         <p:nvSpPr>
-          <p:cNvPr id="281" name="TextBox 3"/>
+          <p:cNvPr id="278" name="TextBox 3"/>
           <p:cNvSpPr/>
           <p:nvPr/>
         </p:nvSpPr>
@@ -8814,7 +8582,7 @@
       </p:sp>
       <p:sp>
         <p:nvSpPr>
-          <p:cNvPr id="282" name="TextBox 4"/>
+          <p:cNvPr id="279" name="TextBox 4"/>
           <p:cNvSpPr/>
           <p:nvPr/>
         </p:nvSpPr>
@@ -8867,7 +8635,7 @@
       </p:sp>
       <p:sp>
         <p:nvSpPr>
-          <p:cNvPr id="283" name="TextBox 5"/>
+          <p:cNvPr id="280" name="TextBox 5"/>
           <p:cNvSpPr/>
           <p:nvPr/>
         </p:nvSpPr>
@@ -8920,7 +8688,7 @@
       </p:sp>
       <p:sp>
         <p:nvSpPr>
-          <p:cNvPr id="284" name="TextBox 6"/>
+          <p:cNvPr id="281" name="TextBox 6"/>
           <p:cNvSpPr/>
           <p:nvPr/>
         </p:nvSpPr>
@@ -8973,7 +8741,7 @@
       </p:sp>
       <p:sp>
         <p:nvSpPr>
-          <p:cNvPr id="285" name="TextBox 7"/>
+          <p:cNvPr id="282" name="TextBox 7"/>
           <p:cNvSpPr/>
           <p:nvPr/>
         </p:nvSpPr>
@@ -9026,7 +8794,7 @@
       </p:sp>
       <p:sp>
         <p:nvSpPr>
-          <p:cNvPr id="286" name="Rectangle 8"/>
+          <p:cNvPr id="283" name="Rectangle 8"/>
           <p:cNvSpPr/>
           <p:nvPr/>
         </p:nvSpPr>
@@ -9087,7 +8855,7 @@
       </p:sp>
       <p:sp>
         <p:nvSpPr>
-          <p:cNvPr id="287" name="TextBox 9"/>
+          <p:cNvPr id="284" name="TextBox 9"/>
           <p:cNvSpPr/>
           <p:nvPr/>
         </p:nvSpPr>
@@ -9140,7 +8908,7 @@
       </p:sp>
       <p:sp>
         <p:nvSpPr>
-          <p:cNvPr id="288" name="TextBox 10"/>
+          <p:cNvPr id="285" name="TextBox 10"/>
           <p:cNvSpPr/>
           <p:nvPr/>
         </p:nvSpPr>
@@ -9193,7 +8961,7 @@
       </p:sp>
       <p:sp>
         <p:nvSpPr>
-          <p:cNvPr id="289" name="TextBox 11"/>
+          <p:cNvPr id="286" name="TextBox 11"/>
           <p:cNvSpPr/>
           <p:nvPr/>
         </p:nvSpPr>
@@ -9246,7 +9014,7 @@
       </p:sp>
       <p:sp>
         <p:nvSpPr>
-          <p:cNvPr id="290" name="Rectangle 12"/>
+          <p:cNvPr id="287" name="Rectangle 12"/>
           <p:cNvSpPr/>
           <p:nvPr/>
         </p:nvSpPr>
@@ -9307,7 +9075,7 @@
       </p:sp>
       <p:sp>
         <p:nvSpPr>
-          <p:cNvPr id="291" name="TextBox 13"/>
+          <p:cNvPr id="288" name="TextBox 13"/>
           <p:cNvSpPr/>
           <p:nvPr/>
         </p:nvSpPr>
@@ -9360,7 +9128,7 @@
       </p:sp>
       <p:sp>
         <p:nvSpPr>
-          <p:cNvPr id="292" name="TextBox 14"/>
+          <p:cNvPr id="289" name="TextBox 14"/>
           <p:cNvSpPr/>
           <p:nvPr/>
         </p:nvSpPr>
@@ -9413,7 +9181,7 @@
       </p:sp>
       <p:sp>
         <p:nvSpPr>
-          <p:cNvPr id="293" name="TextBox 15"/>
+          <p:cNvPr id="290" name="TextBox 15"/>
           <p:cNvSpPr/>
           <p:nvPr/>
         </p:nvSpPr>
@@ -9466,7 +9234,7 @@
       </p:sp>
       <p:sp>
         <p:nvSpPr>
-          <p:cNvPr id="294" name="Rectangle 16"/>
+          <p:cNvPr id="291" name="Rectangle 16"/>
           <p:cNvSpPr/>
           <p:nvPr/>
         </p:nvSpPr>
@@ -9527,7 +9295,7 @@
       </p:sp>
       <p:sp>
         <p:nvSpPr>
-          <p:cNvPr id="295" name="TextBox 17"/>
+          <p:cNvPr id="292" name="TextBox 17"/>
           <p:cNvSpPr/>
           <p:nvPr/>
         </p:nvSpPr>
@@ -9580,7 +9348,7 @@
       </p:sp>
       <p:sp>
         <p:nvSpPr>
-          <p:cNvPr id="296" name="TextBox 18"/>
+          <p:cNvPr id="293" name="TextBox 18"/>
           <p:cNvSpPr/>
           <p:nvPr/>
         </p:nvSpPr>
@@ -9633,7 +9401,7 @@
       </p:sp>
       <p:sp>
         <p:nvSpPr>
-          <p:cNvPr id="297" name="TextBox 19"/>
+          <p:cNvPr id="294" name="TextBox 19"/>
           <p:cNvSpPr/>
           <p:nvPr/>
         </p:nvSpPr>
@@ -9686,7 +9454,7 @@
       </p:sp>
       <p:sp>
         <p:nvSpPr>
-          <p:cNvPr id="298" name="Rectangle 20"/>
+          <p:cNvPr id="295" name="Rectangle 20"/>
           <p:cNvSpPr/>
           <p:nvPr/>
         </p:nvSpPr>
@@ -9747,7 +9515,7 @@
       </p:sp>
       <p:sp>
         <p:nvSpPr>
-          <p:cNvPr id="299" name="TextBox 21"/>
+          <p:cNvPr id="296" name="TextBox 21"/>
           <p:cNvSpPr/>
           <p:nvPr/>
         </p:nvSpPr>
@@ -9800,7 +9568,7 @@
       </p:sp>
       <p:sp>
         <p:nvSpPr>
-          <p:cNvPr id="300" name="TextBox 22"/>
+          <p:cNvPr id="297" name="TextBox 22"/>
           <p:cNvSpPr/>
           <p:nvPr/>
         </p:nvSpPr>
@@ -9853,7 +9621,7 @@
       </p:sp>
       <p:sp>
         <p:nvSpPr>
-          <p:cNvPr id="301" name="TextBox 23"/>
+          <p:cNvPr id="298" name="TextBox 23"/>
           <p:cNvSpPr/>
           <p:nvPr/>
         </p:nvSpPr>
@@ -9906,7 +9674,7 @@
       </p:sp>
       <p:sp>
         <p:nvSpPr>
-          <p:cNvPr id="302" name="Rectangle 24"/>
+          <p:cNvPr id="299" name="Rectangle 24"/>
           <p:cNvSpPr/>
           <p:nvPr/>
         </p:nvSpPr>
@@ -9967,7 +9735,7 @@
       </p:sp>
       <p:sp>
         <p:nvSpPr>
-          <p:cNvPr id="303" name="Rectangle 25"/>
+          <p:cNvPr id="300" name="Rectangle 25"/>
           <p:cNvSpPr/>
           <p:nvPr/>
         </p:nvSpPr>
@@ -10026,7 +9794,7 @@
       </p:sp>
       <p:sp>
         <p:nvSpPr>
-          <p:cNvPr id="304" name="TextBox 26"/>
+          <p:cNvPr id="301" name="TextBox 26"/>
           <p:cNvSpPr/>
           <p:nvPr/>
         </p:nvSpPr>
@@ -10079,7 +9847,7 @@
       </p:sp>
       <p:sp>
         <p:nvSpPr>
-          <p:cNvPr id="305" name="TextBox 27"/>
+          <p:cNvPr id="302" name="TextBox 27"/>
           <p:cNvSpPr/>
           <p:nvPr/>
         </p:nvSpPr>
@@ -10132,7 +9900,7 @@
       </p:sp>
       <p:sp>
         <p:nvSpPr>
-          <p:cNvPr id="306" name="TextBox 28"/>
+          <p:cNvPr id="303" name="TextBox 28"/>
           <p:cNvSpPr/>
           <p:nvPr/>
         </p:nvSpPr>
@@ -10201,17 +9969,9 @@
   <p:cSld>
     <p:bg>
       <p:bgPr>
-        <a:gradFill rotWithShape="0">
-          <a:gsLst>
-            <a:gs pos="0">
-              <a:srgbClr val="918ef4"/>
-            </a:gs>
-            <a:gs pos="100000">
-              <a:srgbClr val="6f6cd9"/>
-            </a:gs>
-          </a:gsLst>
-          <a:lin ang="2700000"/>
-        </a:gradFill>
+        <a:solidFill>
+          <a:srgbClr val="918ef4"/>
+        </a:solidFill>
       </p:bgPr>
     </p:bg>
     <p:spTree>
@@ -10230,7 +9990,7 @@
       </p:grpSpPr>
       <p:sp>
         <p:nvSpPr>
-          <p:cNvPr id="307" name="TextBox 1"/>
+          <p:cNvPr id="304" name="TextBox 1"/>
           <p:cNvSpPr/>
           <p:nvPr/>
         </p:nvSpPr>
@@ -10283,7 +10043,7 @@
       </p:sp>
       <p:sp>
         <p:nvSpPr>
-          <p:cNvPr id="308" name="TextBox 2"/>
+          <p:cNvPr id="305" name="TextBox 2"/>
           <p:cNvSpPr/>
           <p:nvPr/>
         </p:nvSpPr>
@@ -10336,7 +10096,7 @@
       </p:sp>
       <p:sp>
         <p:nvSpPr>
-          <p:cNvPr id="309" name="TextBox 3"/>
+          <p:cNvPr id="306" name="TextBox 3"/>
           <p:cNvSpPr/>
           <p:nvPr/>
         </p:nvSpPr>
@@ -10389,7 +10149,7 @@
       </p:sp>
       <p:sp>
         <p:nvSpPr>
-          <p:cNvPr id="310" name="TextBox 4"/>
+          <p:cNvPr id="307" name="TextBox 4"/>
           <p:cNvSpPr/>
           <p:nvPr/>
         </p:nvSpPr>
@@ -10442,7 +10202,7 @@
       </p:sp>
       <p:sp>
         <p:nvSpPr>
-          <p:cNvPr id="311" name="Rounded Rectangle 5"/>
+          <p:cNvPr id="308" name="Rounded Rectangle 5"/>
           <p:cNvSpPr/>
           <p:nvPr/>
         </p:nvSpPr>
@@ -10508,7 +10268,7 @@
       </p:sp>
       <p:sp>
         <p:nvSpPr>
-          <p:cNvPr id="312" name="TextBox 6"/>
+          <p:cNvPr id="309" name="TextBox 6"/>
           <p:cNvSpPr/>
           <p:nvPr/>
         </p:nvSpPr>
@@ -10561,7 +10321,7 @@
       </p:sp>
       <p:sp>
         <p:nvSpPr>
-          <p:cNvPr id="313" name="TextBox 7"/>
+          <p:cNvPr id="310" name="TextBox 7"/>
           <p:cNvSpPr/>
           <p:nvPr/>
         </p:nvSpPr>
@@ -10614,7 +10374,7 @@
       </p:sp>
       <p:sp>
         <p:nvSpPr>
-          <p:cNvPr id="314" name="Rounded Rectangle 8"/>
+          <p:cNvPr id="311" name="Rounded Rectangle 8"/>
           <p:cNvSpPr/>
           <p:nvPr/>
         </p:nvSpPr>
@@ -10680,7 +10440,7 @@
       </p:sp>
       <p:sp>
         <p:nvSpPr>
-          <p:cNvPr id="315" name="TextBox 9"/>
+          <p:cNvPr id="312" name="TextBox 9"/>
           <p:cNvSpPr/>
           <p:nvPr/>
         </p:nvSpPr>
@@ -10733,7 +10493,7 @@
       </p:sp>
       <p:sp>
         <p:nvSpPr>
-          <p:cNvPr id="316" name="TextBox 10"/>
+          <p:cNvPr id="313" name="TextBox 10"/>
           <p:cNvSpPr/>
           <p:nvPr/>
         </p:nvSpPr>
@@ -10786,7 +10546,7 @@
       </p:sp>
       <p:sp>
         <p:nvSpPr>
-          <p:cNvPr id="317" name="Rounded Rectangle 11"/>
+          <p:cNvPr id="314" name="Rounded Rectangle 11"/>
           <p:cNvSpPr/>
           <p:nvPr/>
         </p:nvSpPr>
@@ -10852,7 +10612,7 @@
       </p:sp>
       <p:sp>
         <p:nvSpPr>
-          <p:cNvPr id="318" name="TextBox 12"/>
+          <p:cNvPr id="315" name="TextBox 12"/>
           <p:cNvSpPr/>
           <p:nvPr/>
         </p:nvSpPr>
@@ -10905,7 +10665,7 @@
       </p:sp>
       <p:sp>
         <p:nvSpPr>
-          <p:cNvPr id="319" name="TextBox 13"/>
+          <p:cNvPr id="316" name="TextBox 13"/>
           <p:cNvSpPr/>
           <p:nvPr/>
         </p:nvSpPr>
@@ -10958,7 +10718,7 @@
       </p:sp>
       <p:sp>
         <p:nvSpPr>
-          <p:cNvPr id="320" name="TextBox 14"/>
+          <p:cNvPr id="317" name="TextBox 14"/>
           <p:cNvSpPr/>
           <p:nvPr/>
         </p:nvSpPr>
@@ -11011,7 +10771,7 @@
       </p:sp>
       <p:sp>
         <p:nvSpPr>
-          <p:cNvPr id="321" name="Rectangle 15"/>
+          <p:cNvPr id="318" name="Rectangle 15"/>
           <p:cNvSpPr/>
           <p:nvPr/>
         </p:nvSpPr>
@@ -11070,7 +10830,7 @@
       </p:sp>
       <p:sp>
         <p:nvSpPr>
-          <p:cNvPr id="322" name="TextBox 16"/>
+          <p:cNvPr id="319" name="TextBox 16"/>
           <p:cNvSpPr/>
           <p:nvPr/>
         </p:nvSpPr>
@@ -11123,7 +10883,7 @@
       </p:sp>
       <p:sp>
         <p:nvSpPr>
-          <p:cNvPr id="323" name="TextBox 17"/>
+          <p:cNvPr id="320" name="TextBox 17"/>
           <p:cNvSpPr/>
           <p:nvPr/>
         </p:nvSpPr>
@@ -11176,7 +10936,7 @@
       </p:sp>
       <p:sp>
         <p:nvSpPr>
-          <p:cNvPr id="324" name="TextBox 18"/>
+          <p:cNvPr id="321" name="TextBox 18"/>
           <p:cNvSpPr/>
           <p:nvPr/>
         </p:nvSpPr>
@@ -11245,17 +11005,9 @@
   <p:cSld>
     <p:bg>
       <p:bgPr>
-        <a:gradFill rotWithShape="0">
-          <a:gsLst>
-            <a:gs pos="0">
-              <a:srgbClr val="918ef4"/>
-            </a:gs>
-            <a:gs pos="100000">
-              <a:srgbClr val="6f6cd9"/>
-            </a:gs>
-          </a:gsLst>
-          <a:lin ang="2700000"/>
-        </a:gradFill>
+        <a:solidFill>
+          <a:srgbClr val="918ef4"/>
+        </a:solidFill>
       </p:bgPr>
     </p:bg>
     <p:spTree>
@@ -11274,7 +11026,7 @@
       </p:grpSpPr>
       <p:sp>
         <p:nvSpPr>
-          <p:cNvPr id="77" name="TextBox 1"/>
+          <p:cNvPr id="74" name="TextBox 1"/>
           <p:cNvSpPr/>
           <p:nvPr/>
         </p:nvSpPr>
@@ -11327,7 +11079,7 @@
       </p:sp>
       <p:sp>
         <p:nvSpPr>
-          <p:cNvPr id="78" name="TextBox 2"/>
+          <p:cNvPr id="75" name="TextBox 2"/>
           <p:cNvSpPr/>
           <p:nvPr/>
         </p:nvSpPr>
@@ -11380,7 +11132,7 @@
       </p:sp>
       <p:sp>
         <p:nvSpPr>
-          <p:cNvPr id="79" name="TextBox 3"/>
+          <p:cNvPr id="76" name="TextBox 3"/>
           <p:cNvSpPr/>
           <p:nvPr/>
         </p:nvSpPr>
@@ -11433,7 +11185,7 @@
       </p:sp>
       <p:sp>
         <p:nvSpPr>
-          <p:cNvPr id="80" name="TextBox 4"/>
+          <p:cNvPr id="77" name="TextBox 4"/>
           <p:cNvSpPr/>
           <p:nvPr/>
         </p:nvSpPr>
@@ -11486,7 +11238,7 @@
       </p:sp>
       <p:sp>
         <p:nvSpPr>
-          <p:cNvPr id="81" name="Rounded Rectangle 5"/>
+          <p:cNvPr id="78" name="Rounded Rectangle 5"/>
           <p:cNvSpPr/>
           <p:nvPr/>
         </p:nvSpPr>
@@ -11552,7 +11304,7 @@
       </p:sp>
       <p:sp>
         <p:nvSpPr>
-          <p:cNvPr id="82" name="TextBox 6"/>
+          <p:cNvPr id="79" name="TextBox 6"/>
           <p:cNvSpPr/>
           <p:nvPr/>
         </p:nvSpPr>
@@ -11605,7 +11357,7 @@
       </p:sp>
       <p:sp>
         <p:nvSpPr>
-          <p:cNvPr id="83" name="TextBox 7"/>
+          <p:cNvPr id="80" name="TextBox 7"/>
           <p:cNvSpPr/>
           <p:nvPr/>
         </p:nvSpPr>
@@ -11658,7 +11410,7 @@
       </p:sp>
       <p:sp>
         <p:nvSpPr>
-          <p:cNvPr id="84" name="Rounded Rectangle 8"/>
+          <p:cNvPr id="81" name="Rounded Rectangle 8"/>
           <p:cNvSpPr/>
           <p:nvPr/>
         </p:nvSpPr>
@@ -11724,7 +11476,7 @@
       </p:sp>
       <p:sp>
         <p:nvSpPr>
-          <p:cNvPr id="85" name="TextBox 9"/>
+          <p:cNvPr id="82" name="TextBox 9"/>
           <p:cNvSpPr/>
           <p:nvPr/>
         </p:nvSpPr>
@@ -11777,7 +11529,7 @@
       </p:sp>
       <p:sp>
         <p:nvSpPr>
-          <p:cNvPr id="86" name="TextBox 10"/>
+          <p:cNvPr id="83" name="TextBox 10"/>
           <p:cNvSpPr/>
           <p:nvPr/>
         </p:nvSpPr>
@@ -11830,7 +11582,7 @@
       </p:sp>
       <p:sp>
         <p:nvSpPr>
-          <p:cNvPr id="87" name="Rounded Rectangle 11"/>
+          <p:cNvPr id="84" name="Rounded Rectangle 11"/>
           <p:cNvSpPr/>
           <p:nvPr/>
         </p:nvSpPr>
@@ -11896,7 +11648,7 @@
       </p:sp>
       <p:sp>
         <p:nvSpPr>
-          <p:cNvPr id="88" name="TextBox 12"/>
+          <p:cNvPr id="85" name="TextBox 12"/>
           <p:cNvSpPr/>
           <p:nvPr/>
         </p:nvSpPr>
@@ -11949,7 +11701,7 @@
       </p:sp>
       <p:sp>
         <p:nvSpPr>
-          <p:cNvPr id="89" name="TextBox 13"/>
+          <p:cNvPr id="86" name="TextBox 13"/>
           <p:cNvSpPr/>
           <p:nvPr/>
         </p:nvSpPr>
@@ -12002,7 +11754,7 @@
       </p:sp>
       <p:sp>
         <p:nvSpPr>
-          <p:cNvPr id="90" name="Rectangle 14"/>
+          <p:cNvPr id="87" name="Rectangle 14"/>
           <p:cNvSpPr/>
           <p:nvPr/>
         </p:nvSpPr>
@@ -12061,7 +11813,7 @@
       </p:sp>
       <p:sp>
         <p:nvSpPr>
-          <p:cNvPr id="91" name="TextBox 15"/>
+          <p:cNvPr id="88" name="TextBox 15"/>
           <p:cNvSpPr/>
           <p:nvPr/>
         </p:nvSpPr>
@@ -12114,7 +11866,7 @@
       </p:sp>
       <p:sp>
         <p:nvSpPr>
-          <p:cNvPr id="92" name="TextBox 16"/>
+          <p:cNvPr id="89" name="TextBox 16"/>
           <p:cNvSpPr/>
           <p:nvPr/>
         </p:nvSpPr>
@@ -12167,7 +11919,7 @@
       </p:sp>
       <p:sp>
         <p:nvSpPr>
-          <p:cNvPr id="93" name="TextBox 17"/>
+          <p:cNvPr id="90" name="TextBox 17"/>
           <p:cNvSpPr/>
           <p:nvPr/>
         </p:nvSpPr>
@@ -12236,17 +11988,9 @@
   <p:cSld>
     <p:bg>
       <p:bgPr>
-        <a:gradFill rotWithShape="0">
-          <a:gsLst>
-            <a:gs pos="0">
-              <a:srgbClr val="918ef4"/>
-            </a:gs>
-            <a:gs pos="100000">
-              <a:srgbClr val="6f6cd9"/>
-            </a:gs>
-          </a:gsLst>
-          <a:lin ang="2700000"/>
-        </a:gradFill>
+        <a:solidFill>
+          <a:srgbClr val="918ef4"/>
+        </a:solidFill>
       </p:bgPr>
     </p:bg>
     <p:spTree>
@@ -12265,7 +12009,7 @@
       </p:grpSpPr>
       <p:sp>
         <p:nvSpPr>
-          <p:cNvPr id="94" name="TextBox 1"/>
+          <p:cNvPr id="91" name="TextBox 1"/>
           <p:cNvSpPr/>
           <p:nvPr/>
         </p:nvSpPr>
@@ -12318,7 +12062,7 @@
       </p:sp>
       <p:sp>
         <p:nvSpPr>
-          <p:cNvPr id="95" name="TextBox 2"/>
+          <p:cNvPr id="92" name="TextBox 2"/>
           <p:cNvSpPr/>
           <p:nvPr/>
         </p:nvSpPr>
@@ -12371,7 +12115,7 @@
       </p:sp>
       <p:sp>
         <p:nvSpPr>
-          <p:cNvPr id="96" name="TextBox 3"/>
+          <p:cNvPr id="93" name="TextBox 3"/>
           <p:cNvSpPr/>
           <p:nvPr/>
         </p:nvSpPr>
@@ -12424,7 +12168,7 @@
       </p:sp>
       <p:sp>
         <p:nvSpPr>
-          <p:cNvPr id="97" name="TextBox 4"/>
+          <p:cNvPr id="94" name="TextBox 4"/>
           <p:cNvSpPr/>
           <p:nvPr/>
         </p:nvSpPr>
@@ -12477,7 +12221,7 @@
       </p:sp>
       <p:sp>
         <p:nvSpPr>
-          <p:cNvPr id="98" name="Rounded Rectangle 5"/>
+          <p:cNvPr id="95" name="Rounded Rectangle 5"/>
           <p:cNvSpPr/>
           <p:nvPr/>
         </p:nvSpPr>
@@ -12543,7 +12287,7 @@
       </p:sp>
       <p:sp>
         <p:nvSpPr>
-          <p:cNvPr id="99" name="TextBox 6"/>
+          <p:cNvPr id="96" name="TextBox 6"/>
           <p:cNvSpPr/>
           <p:nvPr/>
         </p:nvSpPr>
@@ -12596,7 +12340,7 @@
       </p:sp>
       <p:sp>
         <p:nvSpPr>
-          <p:cNvPr id="100" name="TextBox 7"/>
+          <p:cNvPr id="97" name="TextBox 7"/>
           <p:cNvSpPr/>
           <p:nvPr/>
         </p:nvSpPr>
@@ -12751,7 +12495,7 @@
       </p:sp>
       <p:sp>
         <p:nvSpPr>
-          <p:cNvPr id="101" name="Rounded Rectangle 8"/>
+          <p:cNvPr id="98" name="Rounded Rectangle 8"/>
           <p:cNvSpPr/>
           <p:nvPr/>
         </p:nvSpPr>
@@ -12817,7 +12561,7 @@
       </p:sp>
       <p:sp>
         <p:nvSpPr>
-          <p:cNvPr id="102" name="TextBox 9"/>
+          <p:cNvPr id="99" name="TextBox 9"/>
           <p:cNvSpPr/>
           <p:nvPr/>
         </p:nvSpPr>
@@ -12870,7 +12614,7 @@
       </p:sp>
       <p:sp>
         <p:nvSpPr>
-          <p:cNvPr id="103" name="TextBox 10"/>
+          <p:cNvPr id="100" name="TextBox 10"/>
           <p:cNvSpPr/>
           <p:nvPr/>
         </p:nvSpPr>
@@ -13025,7 +12769,7 @@
       </p:sp>
       <p:sp>
         <p:nvSpPr>
-          <p:cNvPr id="104" name="Rectangle 11"/>
+          <p:cNvPr id="101" name="Rectangle 11"/>
           <p:cNvSpPr/>
           <p:nvPr/>
         </p:nvSpPr>
@@ -13084,7 +12828,7 @@
       </p:sp>
       <p:sp>
         <p:nvSpPr>
-          <p:cNvPr id="105" name="TextBox 12"/>
+          <p:cNvPr id="102" name="TextBox 12"/>
           <p:cNvSpPr/>
           <p:nvPr/>
         </p:nvSpPr>
@@ -13137,7 +12881,7 @@
       </p:sp>
       <p:sp>
         <p:nvSpPr>
-          <p:cNvPr id="106" name="TextBox 13"/>
+          <p:cNvPr id="103" name="TextBox 13"/>
           <p:cNvSpPr/>
           <p:nvPr/>
         </p:nvSpPr>
@@ -13190,7 +12934,7 @@
       </p:sp>
       <p:sp>
         <p:nvSpPr>
-          <p:cNvPr id="107" name="TextBox 14"/>
+          <p:cNvPr id="104" name="TextBox 14"/>
           <p:cNvSpPr/>
           <p:nvPr/>
         </p:nvSpPr>
@@ -13259,17 +13003,9 @@
   <p:cSld>
     <p:bg>
       <p:bgPr>
-        <a:gradFill rotWithShape="0">
-          <a:gsLst>
-            <a:gs pos="0">
-              <a:srgbClr val="918ef4"/>
-            </a:gs>
-            <a:gs pos="100000">
-              <a:srgbClr val="6f6cd9"/>
-            </a:gs>
-          </a:gsLst>
-          <a:lin ang="2700000"/>
-        </a:gradFill>
+        <a:solidFill>
+          <a:srgbClr val="918ef4"/>
+        </a:solidFill>
       </p:bgPr>
     </p:bg>
     <p:spTree>
@@ -13288,7 +13024,7 @@
       </p:grpSpPr>
       <p:sp>
         <p:nvSpPr>
-          <p:cNvPr id="108" name="TextBox 1"/>
+          <p:cNvPr id="105" name="TextBox 1"/>
           <p:cNvSpPr/>
           <p:nvPr/>
         </p:nvSpPr>
@@ -13341,7 +13077,7 @@
       </p:sp>
       <p:sp>
         <p:nvSpPr>
-          <p:cNvPr id="109" name="TextBox 2"/>
+          <p:cNvPr id="106" name="TextBox 2"/>
           <p:cNvSpPr/>
           <p:nvPr/>
         </p:nvSpPr>
@@ -13394,7 +13130,7 @@
       </p:sp>
       <p:sp>
         <p:nvSpPr>
-          <p:cNvPr id="110" name="TextBox 3"/>
+          <p:cNvPr id="107" name="TextBox 3"/>
           <p:cNvSpPr/>
           <p:nvPr/>
         </p:nvSpPr>
@@ -13447,7 +13183,7 @@
       </p:sp>
       <p:sp>
         <p:nvSpPr>
-          <p:cNvPr id="111" name="TextBox 4"/>
+          <p:cNvPr id="108" name="TextBox 4"/>
           <p:cNvSpPr/>
           <p:nvPr/>
         </p:nvSpPr>
@@ -13500,7 +13236,7 @@
       </p:sp>
       <p:sp>
         <p:nvSpPr>
-          <p:cNvPr id="112" name="Rounded Rectangle 5"/>
+          <p:cNvPr id="109" name="Rounded Rectangle 5"/>
           <p:cNvSpPr/>
           <p:nvPr/>
         </p:nvSpPr>
@@ -13566,7 +13302,7 @@
       </p:sp>
       <p:sp>
         <p:nvSpPr>
-          <p:cNvPr id="113" name="TextBox 6"/>
+          <p:cNvPr id="110" name="TextBox 6"/>
           <p:cNvSpPr/>
           <p:nvPr/>
         </p:nvSpPr>
@@ -13663,7 +13399,7 @@
       </p:sp>
       <p:sp>
         <p:nvSpPr>
-          <p:cNvPr id="114" name="Rectangle 7"/>
+          <p:cNvPr id="111" name="Rectangle 7"/>
           <p:cNvSpPr/>
           <p:nvPr/>
         </p:nvSpPr>
@@ -13722,7 +13458,7 @@
       </p:sp>
       <p:sp>
         <p:nvSpPr>
-          <p:cNvPr id="115" name="TextBox 8"/>
+          <p:cNvPr id="112" name="TextBox 8"/>
           <p:cNvSpPr/>
           <p:nvPr/>
         </p:nvSpPr>
@@ -13775,7 +13511,7 @@
       </p:sp>
       <p:sp>
         <p:nvSpPr>
-          <p:cNvPr id="116" name="TextBox 9"/>
+          <p:cNvPr id="113" name="TextBox 9"/>
           <p:cNvSpPr/>
           <p:nvPr/>
         </p:nvSpPr>
@@ -13828,7 +13564,7 @@
       </p:sp>
       <p:sp>
         <p:nvSpPr>
-          <p:cNvPr id="117" name="TextBox 10"/>
+          <p:cNvPr id="114" name="TextBox 10"/>
           <p:cNvSpPr/>
           <p:nvPr/>
         </p:nvSpPr>
@@ -13897,17 +13633,9 @@
   <p:cSld>
     <p:bg>
       <p:bgPr>
-        <a:gradFill rotWithShape="0">
-          <a:gsLst>
-            <a:gs pos="0">
-              <a:srgbClr val="918ef4"/>
-            </a:gs>
-            <a:gs pos="100000">
-              <a:srgbClr val="6f6cd9"/>
-            </a:gs>
-          </a:gsLst>
-          <a:lin ang="2700000"/>
-        </a:gradFill>
+        <a:solidFill>
+          <a:srgbClr val="918ef4"/>
+        </a:solidFill>
       </p:bgPr>
     </p:bg>
     <p:spTree>
@@ -13926,7 +13654,7 @@
       </p:grpSpPr>
       <p:sp>
         <p:nvSpPr>
-          <p:cNvPr id="118" name="TextBox 1"/>
+          <p:cNvPr id="115" name="TextBox 1"/>
           <p:cNvSpPr/>
           <p:nvPr/>
         </p:nvSpPr>
@@ -13979,7 +13707,7 @@
       </p:sp>
       <p:sp>
         <p:nvSpPr>
-          <p:cNvPr id="119" name="TextBox 2"/>
+          <p:cNvPr id="116" name="TextBox 2"/>
           <p:cNvSpPr/>
           <p:nvPr/>
         </p:nvSpPr>
@@ -14032,7 +13760,7 @@
       </p:sp>
       <p:sp>
         <p:nvSpPr>
-          <p:cNvPr id="120" name="TextBox 3"/>
+          <p:cNvPr id="117" name="TextBox 3"/>
           <p:cNvSpPr/>
           <p:nvPr/>
         </p:nvSpPr>
@@ -14085,7 +13813,7 @@
       </p:sp>
       <p:sp>
         <p:nvSpPr>
-          <p:cNvPr id="121" name="TextBox 4"/>
+          <p:cNvPr id="118" name="TextBox 4"/>
           <p:cNvSpPr/>
           <p:nvPr/>
         </p:nvSpPr>
@@ -14138,7 +13866,7 @@
       </p:sp>
       <p:sp>
         <p:nvSpPr>
-          <p:cNvPr id="122" name="Oval 5"/>
+          <p:cNvPr id="119" name="Oval 5"/>
           <p:cNvSpPr/>
           <p:nvPr/>
         </p:nvSpPr>
@@ -14197,7 +13925,7 @@
       </p:sp>
       <p:sp>
         <p:nvSpPr>
-          <p:cNvPr id="123" name="TextBox 6"/>
+          <p:cNvPr id="120" name="TextBox 6"/>
           <p:cNvSpPr/>
           <p:nvPr/>
         </p:nvSpPr>
@@ -14250,7 +13978,7 @@
       </p:sp>
       <p:sp>
         <p:nvSpPr>
-          <p:cNvPr id="124" name="TextBox 7"/>
+          <p:cNvPr id="121" name="TextBox 7"/>
           <p:cNvSpPr/>
           <p:nvPr/>
         </p:nvSpPr>
@@ -14303,7 +14031,7 @@
       </p:sp>
       <p:sp>
         <p:nvSpPr>
-          <p:cNvPr id="125" name="TextBox 8"/>
+          <p:cNvPr id="122" name="TextBox 8"/>
           <p:cNvSpPr/>
           <p:nvPr/>
         </p:nvSpPr>
@@ -14356,7 +14084,7 @@
       </p:sp>
       <p:sp>
         <p:nvSpPr>
-          <p:cNvPr id="126" name="Oval 9"/>
+          <p:cNvPr id="123" name="Oval 9"/>
           <p:cNvSpPr/>
           <p:nvPr/>
         </p:nvSpPr>
@@ -14415,7 +14143,7 @@
       </p:sp>
       <p:sp>
         <p:nvSpPr>
-          <p:cNvPr id="127" name="TextBox 10"/>
+          <p:cNvPr id="124" name="TextBox 10"/>
           <p:cNvSpPr/>
           <p:nvPr/>
         </p:nvSpPr>
@@ -14468,7 +14196,7 @@
       </p:sp>
       <p:sp>
         <p:nvSpPr>
-          <p:cNvPr id="128" name="TextBox 11"/>
+          <p:cNvPr id="125" name="TextBox 11"/>
           <p:cNvSpPr/>
           <p:nvPr/>
         </p:nvSpPr>
@@ -14521,7 +14249,7 @@
       </p:sp>
       <p:sp>
         <p:nvSpPr>
-          <p:cNvPr id="129" name="TextBox 12"/>
+          <p:cNvPr id="126" name="TextBox 12"/>
           <p:cNvSpPr/>
           <p:nvPr/>
         </p:nvSpPr>
@@ -14574,7 +14302,7 @@
       </p:sp>
       <p:sp>
         <p:nvSpPr>
-          <p:cNvPr id="130" name="Oval 13"/>
+          <p:cNvPr id="127" name="Oval 13"/>
           <p:cNvSpPr/>
           <p:nvPr/>
         </p:nvSpPr>
@@ -14633,7 +14361,7 @@
       </p:sp>
       <p:sp>
         <p:nvSpPr>
-          <p:cNvPr id="131" name="TextBox 14"/>
+          <p:cNvPr id="128" name="TextBox 14"/>
           <p:cNvSpPr/>
           <p:nvPr/>
         </p:nvSpPr>
@@ -14686,7 +14414,7 @@
       </p:sp>
       <p:sp>
         <p:nvSpPr>
-          <p:cNvPr id="132" name="TextBox 15"/>
+          <p:cNvPr id="129" name="TextBox 15"/>
           <p:cNvSpPr/>
           <p:nvPr/>
         </p:nvSpPr>
@@ -14739,7 +14467,7 @@
       </p:sp>
       <p:sp>
         <p:nvSpPr>
-          <p:cNvPr id="133" name="TextBox 16"/>
+          <p:cNvPr id="130" name="TextBox 16"/>
           <p:cNvSpPr/>
           <p:nvPr/>
         </p:nvSpPr>
@@ -14792,7 +14520,7 @@
       </p:sp>
       <p:sp>
         <p:nvSpPr>
-          <p:cNvPr id="134" name="Oval 17"/>
+          <p:cNvPr id="131" name="Oval 17"/>
           <p:cNvSpPr/>
           <p:nvPr/>
         </p:nvSpPr>
@@ -14851,7 +14579,7 @@
       </p:sp>
       <p:sp>
         <p:nvSpPr>
-          <p:cNvPr id="135" name="TextBox 18"/>
+          <p:cNvPr id="132" name="TextBox 18"/>
           <p:cNvSpPr/>
           <p:nvPr/>
         </p:nvSpPr>
@@ -14904,7 +14632,7 @@
       </p:sp>
       <p:sp>
         <p:nvSpPr>
-          <p:cNvPr id="136" name="TextBox 19"/>
+          <p:cNvPr id="133" name="TextBox 19"/>
           <p:cNvSpPr/>
           <p:nvPr/>
         </p:nvSpPr>
@@ -14957,7 +14685,7 @@
       </p:sp>
       <p:sp>
         <p:nvSpPr>
-          <p:cNvPr id="137" name="TextBox 20"/>
+          <p:cNvPr id="134" name="TextBox 20"/>
           <p:cNvSpPr/>
           <p:nvPr/>
         </p:nvSpPr>
@@ -15010,7 +14738,7 @@
       </p:sp>
       <p:cxnSp>
         <p:nvCxnSpPr>
-          <p:cNvPr id="138" name="Connector 21"/>
+          <p:cNvPr id="135" name="Connector 21"/>
           <p:cNvCxnSpPr/>
           <p:nvPr/>
         </p:nvCxnSpPr>
@@ -15034,7 +14762,7 @@
       </p:cxnSp>
       <p:cxnSp>
         <p:nvCxnSpPr>
-          <p:cNvPr id="139" name="Connector 22"/>
+          <p:cNvPr id="136" name="Connector 22"/>
           <p:cNvCxnSpPr/>
           <p:nvPr/>
         </p:nvCxnSpPr>
@@ -15058,7 +14786,7 @@
       </p:cxnSp>
       <p:cxnSp>
         <p:nvCxnSpPr>
-          <p:cNvPr id="140" name="Connector 23"/>
+          <p:cNvPr id="137" name="Connector 23"/>
           <p:cNvCxnSpPr/>
           <p:nvPr/>
         </p:nvCxnSpPr>
@@ -15082,7 +14810,7 @@
       </p:cxnSp>
       <p:sp>
         <p:nvSpPr>
-          <p:cNvPr id="141" name="TextBox 24"/>
+          <p:cNvPr id="138" name="TextBox 24"/>
           <p:cNvSpPr/>
           <p:nvPr/>
         </p:nvSpPr>
@@ -15135,7 +14863,7 @@
       </p:sp>
       <p:sp>
         <p:nvSpPr>
-          <p:cNvPr id="142" name="Rectangle 25"/>
+          <p:cNvPr id="139" name="Rectangle 25"/>
           <p:cNvSpPr/>
           <p:nvPr/>
         </p:nvSpPr>
@@ -15194,7 +14922,7 @@
       </p:sp>
       <p:sp>
         <p:nvSpPr>
-          <p:cNvPr id="143" name="TextBox 26"/>
+          <p:cNvPr id="140" name="TextBox 26"/>
           <p:cNvSpPr/>
           <p:nvPr/>
         </p:nvSpPr>
@@ -15247,7 +14975,7 @@
       </p:sp>
       <p:sp>
         <p:nvSpPr>
-          <p:cNvPr id="144" name="TextBox 27"/>
+          <p:cNvPr id="141" name="TextBox 27"/>
           <p:cNvSpPr/>
           <p:nvPr/>
         </p:nvSpPr>
@@ -15300,7 +15028,7 @@
       </p:sp>
       <p:sp>
         <p:nvSpPr>
-          <p:cNvPr id="145" name="TextBox 28"/>
+          <p:cNvPr id="142" name="TextBox 28"/>
           <p:cNvSpPr/>
           <p:nvPr/>
         </p:nvSpPr>
@@ -15369,17 +15097,9 @@
   <p:cSld>
     <p:bg>
       <p:bgPr>
-        <a:gradFill rotWithShape="0">
-          <a:gsLst>
-            <a:gs pos="0">
-              <a:srgbClr val="918ef4"/>
-            </a:gs>
-            <a:gs pos="100000">
-              <a:srgbClr val="6f6cd9"/>
-            </a:gs>
-          </a:gsLst>
-          <a:lin ang="2700000"/>
-        </a:gradFill>
+        <a:solidFill>
+          <a:srgbClr val="918ef4"/>
+        </a:solidFill>
       </p:bgPr>
     </p:bg>
     <p:spTree>
@@ -15398,7 +15118,7 @@
       </p:grpSpPr>
       <p:sp>
         <p:nvSpPr>
-          <p:cNvPr id="146" name="TextBox 1"/>
+          <p:cNvPr id="143" name="TextBox 1"/>
           <p:cNvSpPr/>
           <p:nvPr/>
         </p:nvSpPr>
@@ -15451,7 +15171,7 @@
       </p:sp>
       <p:sp>
         <p:nvSpPr>
-          <p:cNvPr id="147" name="TextBox 2"/>
+          <p:cNvPr id="144" name="TextBox 2"/>
           <p:cNvSpPr/>
           <p:nvPr/>
         </p:nvSpPr>
@@ -15504,7 +15224,7 @@
       </p:sp>
       <p:sp>
         <p:nvSpPr>
-          <p:cNvPr id="148" name="TextBox 3"/>
+          <p:cNvPr id="145" name="TextBox 3"/>
           <p:cNvSpPr/>
           <p:nvPr/>
         </p:nvSpPr>
@@ -15557,7 +15277,7 @@
       </p:sp>
       <p:sp>
         <p:nvSpPr>
-          <p:cNvPr id="149" name="TextBox 4"/>
+          <p:cNvPr id="146" name="TextBox 4"/>
           <p:cNvSpPr/>
           <p:nvPr/>
         </p:nvSpPr>
@@ -15610,7 +15330,7 @@
       </p:sp>
       <p:sp>
         <p:nvSpPr>
-          <p:cNvPr id="150" name="Rounded Rectangle 5"/>
+          <p:cNvPr id="147" name="Rounded Rectangle 5"/>
           <p:cNvSpPr/>
           <p:nvPr/>
         </p:nvSpPr>
@@ -15676,7 +15396,7 @@
       </p:sp>
       <p:sp>
         <p:nvSpPr>
-          <p:cNvPr id="151" name="TextBox 6"/>
+          <p:cNvPr id="148" name="TextBox 6"/>
           <p:cNvSpPr/>
           <p:nvPr/>
         </p:nvSpPr>
@@ -15729,7 +15449,7 @@
       </p:sp>
       <p:sp>
         <p:nvSpPr>
-          <p:cNvPr id="152" name="TextBox 7"/>
+          <p:cNvPr id="149" name="TextBox 7"/>
           <p:cNvSpPr/>
           <p:nvPr/>
         </p:nvSpPr>
@@ -15782,7 +15502,7 @@
       </p:sp>
       <p:sp>
         <p:nvSpPr>
-          <p:cNvPr id="153" name="Rounded Rectangle 8"/>
+          <p:cNvPr id="150" name="Rounded Rectangle 8"/>
           <p:cNvSpPr/>
           <p:nvPr/>
         </p:nvSpPr>
@@ -15848,7 +15568,7 @@
       </p:sp>
       <p:sp>
         <p:nvSpPr>
-          <p:cNvPr id="154" name="TextBox 9"/>
+          <p:cNvPr id="151" name="TextBox 9"/>
           <p:cNvSpPr/>
           <p:nvPr/>
         </p:nvSpPr>
@@ -15901,7 +15621,7 @@
       </p:sp>
       <p:sp>
         <p:nvSpPr>
-          <p:cNvPr id="155" name="TextBox 10"/>
+          <p:cNvPr id="152" name="TextBox 10"/>
           <p:cNvSpPr/>
           <p:nvPr/>
         </p:nvSpPr>
@@ -15954,7 +15674,7 @@
       </p:sp>
       <p:sp>
         <p:nvSpPr>
-          <p:cNvPr id="156" name="Rounded Rectangle 11"/>
+          <p:cNvPr id="153" name="Rounded Rectangle 11"/>
           <p:cNvSpPr/>
           <p:nvPr/>
         </p:nvSpPr>
@@ -16020,7 +15740,7 @@
       </p:sp>
       <p:sp>
         <p:nvSpPr>
-          <p:cNvPr id="157" name="TextBox 12"/>
+          <p:cNvPr id="154" name="TextBox 12"/>
           <p:cNvSpPr/>
           <p:nvPr/>
         </p:nvSpPr>
@@ -16073,7 +15793,7 @@
       </p:sp>
       <p:sp>
         <p:nvSpPr>
-          <p:cNvPr id="158" name="TextBox 13"/>
+          <p:cNvPr id="155" name="TextBox 13"/>
           <p:cNvSpPr/>
           <p:nvPr/>
         </p:nvSpPr>
@@ -16126,7 +15846,7 @@
       </p:sp>
       <p:sp>
         <p:nvSpPr>
-          <p:cNvPr id="159" name="Rounded Rectangle 14"/>
+          <p:cNvPr id="156" name="Rounded Rectangle 14"/>
           <p:cNvSpPr/>
           <p:nvPr/>
         </p:nvSpPr>
@@ -16192,7 +15912,7 @@
       </p:sp>
       <p:sp>
         <p:nvSpPr>
-          <p:cNvPr id="160" name="TextBox 15"/>
+          <p:cNvPr id="157" name="TextBox 15"/>
           <p:cNvSpPr/>
           <p:nvPr/>
         </p:nvSpPr>
@@ -16245,7 +15965,7 @@
       </p:sp>
       <p:sp>
         <p:nvSpPr>
-          <p:cNvPr id="161" name="TextBox 16"/>
+          <p:cNvPr id="158" name="TextBox 16"/>
           <p:cNvSpPr/>
           <p:nvPr/>
         </p:nvSpPr>
@@ -16298,7 +16018,7 @@
       </p:sp>
       <p:sp>
         <p:nvSpPr>
-          <p:cNvPr id="162" name="Rounded Rectangle 17"/>
+          <p:cNvPr id="159" name="Rounded Rectangle 17"/>
           <p:cNvSpPr/>
           <p:nvPr/>
         </p:nvSpPr>
@@ -16364,7 +16084,7 @@
       </p:sp>
       <p:sp>
         <p:nvSpPr>
-          <p:cNvPr id="163" name="TextBox 18"/>
+          <p:cNvPr id="160" name="TextBox 18"/>
           <p:cNvSpPr/>
           <p:nvPr/>
         </p:nvSpPr>
@@ -16417,7 +16137,7 @@
       </p:sp>
       <p:sp>
         <p:nvSpPr>
-          <p:cNvPr id="164" name="TextBox 19"/>
+          <p:cNvPr id="161" name="TextBox 19"/>
           <p:cNvSpPr/>
           <p:nvPr/>
         </p:nvSpPr>
@@ -16470,7 +16190,7 @@
       </p:sp>
       <p:sp>
         <p:nvSpPr>
-          <p:cNvPr id="165" name="Rounded Rectangle 20"/>
+          <p:cNvPr id="162" name="Rounded Rectangle 20"/>
           <p:cNvSpPr/>
           <p:nvPr/>
         </p:nvSpPr>
@@ -16536,7 +16256,7 @@
       </p:sp>
       <p:sp>
         <p:nvSpPr>
-          <p:cNvPr id="166" name="TextBox 21"/>
+          <p:cNvPr id="163" name="TextBox 21"/>
           <p:cNvSpPr/>
           <p:nvPr/>
         </p:nvSpPr>
@@ -16589,7 +16309,7 @@
       </p:sp>
       <p:sp>
         <p:nvSpPr>
-          <p:cNvPr id="167" name="TextBox 22"/>
+          <p:cNvPr id="164" name="TextBox 22"/>
           <p:cNvSpPr/>
           <p:nvPr/>
         </p:nvSpPr>
@@ -16642,7 +16362,7 @@
       </p:sp>
       <p:sp>
         <p:nvSpPr>
-          <p:cNvPr id="168" name="TextBox 23"/>
+          <p:cNvPr id="165" name="TextBox 23"/>
           <p:cNvSpPr/>
           <p:nvPr/>
         </p:nvSpPr>
@@ -16695,7 +16415,7 @@
       </p:sp>
       <p:sp>
         <p:nvSpPr>
-          <p:cNvPr id="169" name="TextBox 24"/>
+          <p:cNvPr id="166" name="TextBox 24"/>
           <p:cNvSpPr/>
           <p:nvPr/>
         </p:nvSpPr>
@@ -16748,7 +16468,7 @@
       </p:sp>
       <p:sp>
         <p:nvSpPr>
-          <p:cNvPr id="170" name="Rectangle 25"/>
+          <p:cNvPr id="167" name="Rectangle 25"/>
           <p:cNvSpPr/>
           <p:nvPr/>
         </p:nvSpPr>
@@ -16807,7 +16527,7 @@
       </p:sp>
       <p:sp>
         <p:nvSpPr>
-          <p:cNvPr id="171" name="TextBox 26"/>
+          <p:cNvPr id="168" name="TextBox 26"/>
           <p:cNvSpPr/>
           <p:nvPr/>
         </p:nvSpPr>
@@ -16860,7 +16580,7 @@
       </p:sp>
       <p:sp>
         <p:nvSpPr>
-          <p:cNvPr id="172" name="TextBox 27"/>
+          <p:cNvPr id="169" name="TextBox 27"/>
           <p:cNvSpPr/>
           <p:nvPr/>
         </p:nvSpPr>
@@ -16913,7 +16633,7 @@
       </p:sp>
       <p:sp>
         <p:nvSpPr>
-          <p:cNvPr id="173" name="TextBox 28"/>
+          <p:cNvPr id="170" name="TextBox 28"/>
           <p:cNvSpPr/>
           <p:nvPr/>
         </p:nvSpPr>
@@ -16982,17 +16702,9 @@
   <p:cSld>
     <p:bg>
       <p:bgPr>
-        <a:gradFill rotWithShape="0">
-          <a:gsLst>
-            <a:gs pos="0">
-              <a:srgbClr val="918ef4"/>
-            </a:gs>
-            <a:gs pos="100000">
-              <a:srgbClr val="6f6cd9"/>
-            </a:gs>
-          </a:gsLst>
-          <a:lin ang="2700000"/>
-        </a:gradFill>
+        <a:solidFill>
+          <a:srgbClr val="918ef4"/>
+        </a:solidFill>
       </p:bgPr>
     </p:bg>
     <p:spTree>
@@ -17011,7 +16723,7 @@
       </p:grpSpPr>
       <p:sp>
         <p:nvSpPr>
-          <p:cNvPr id="174" name="TextBox 1"/>
+          <p:cNvPr id="171" name="TextBox 1"/>
           <p:cNvSpPr/>
           <p:nvPr/>
         </p:nvSpPr>
@@ -17064,7 +16776,7 @@
       </p:sp>
       <p:sp>
         <p:nvSpPr>
-          <p:cNvPr id="175" name="TextBox 2"/>
+          <p:cNvPr id="172" name="TextBox 2"/>
           <p:cNvSpPr/>
           <p:nvPr/>
         </p:nvSpPr>
@@ -17117,7 +16829,7 @@
       </p:sp>
       <p:sp>
         <p:nvSpPr>
-          <p:cNvPr id="176" name="TextBox 3"/>
+          <p:cNvPr id="173" name="TextBox 3"/>
           <p:cNvSpPr/>
           <p:nvPr/>
         </p:nvSpPr>
@@ -17170,7 +16882,7 @@
       </p:sp>
       <p:sp>
         <p:nvSpPr>
-          <p:cNvPr id="177" name="TextBox 4"/>
+          <p:cNvPr id="174" name="TextBox 4"/>
           <p:cNvSpPr/>
           <p:nvPr/>
         </p:nvSpPr>
@@ -17223,7 +16935,7 @@
       </p:sp>
       <p:sp>
         <p:nvSpPr>
-          <p:cNvPr id="178" name="Rounded Rectangle 5"/>
+          <p:cNvPr id="175" name="Rounded Rectangle 5"/>
           <p:cNvSpPr/>
           <p:nvPr/>
         </p:nvSpPr>
@@ -17286,7 +16998,7 @@
       </p:sp>
       <p:sp>
         <p:nvSpPr>
-          <p:cNvPr id="179" name="TextBox 6"/>
+          <p:cNvPr id="176" name="TextBox 6"/>
           <p:cNvSpPr/>
           <p:nvPr/>
         </p:nvSpPr>
@@ -17339,7 +17051,7 @@
       </p:sp>
       <p:sp>
         <p:nvSpPr>
-          <p:cNvPr id="180" name="TextBox 7"/>
+          <p:cNvPr id="177" name="TextBox 7"/>
           <p:cNvSpPr/>
           <p:nvPr/>
         </p:nvSpPr>
@@ -17392,7 +17104,7 @@
       </p:sp>
       <p:cxnSp>
         <p:nvCxnSpPr>
-          <p:cNvPr id="181" name="Connector 8"/>
+          <p:cNvPr id="178" name="Connector 8"/>
           <p:cNvCxnSpPr/>
           <p:nvPr/>
         </p:nvCxnSpPr>
@@ -17416,7 +17128,7 @@
       </p:cxnSp>
       <p:sp>
         <p:nvSpPr>
-          <p:cNvPr id="182" name="Rounded Rectangle 9"/>
+          <p:cNvPr id="179" name="Rounded Rectangle 9"/>
           <p:cNvSpPr/>
           <p:nvPr/>
         </p:nvSpPr>
@@ -17479,7 +17191,7 @@
       </p:sp>
       <p:sp>
         <p:nvSpPr>
-          <p:cNvPr id="183" name="TextBox 10"/>
+          <p:cNvPr id="180" name="TextBox 10"/>
           <p:cNvSpPr/>
           <p:nvPr/>
         </p:nvSpPr>
@@ -17532,7 +17244,7 @@
       </p:sp>
       <p:sp>
         <p:nvSpPr>
-          <p:cNvPr id="184" name="TextBox 11"/>
+          <p:cNvPr id="181" name="TextBox 11"/>
           <p:cNvSpPr/>
           <p:nvPr/>
         </p:nvSpPr>
@@ -17585,7 +17297,7 @@
       </p:sp>
       <p:cxnSp>
         <p:nvCxnSpPr>
-          <p:cNvPr id="185" name="Connector 12"/>
+          <p:cNvPr id="182" name="Connector 12"/>
           <p:cNvCxnSpPr/>
           <p:nvPr/>
         </p:nvCxnSpPr>
@@ -17607,7 +17319,7 @@
       </p:cxnSp>
       <p:cxnSp>
         <p:nvCxnSpPr>
-          <p:cNvPr id="186" name="Connector 13"/>
+          <p:cNvPr id="183" name="Connector 13"/>
           <p:cNvCxnSpPr/>
           <p:nvPr/>
         </p:nvCxnSpPr>
@@ -17629,7 +17341,7 @@
       </p:cxnSp>
       <p:cxnSp>
         <p:nvCxnSpPr>
-          <p:cNvPr id="187" name="Connector 14"/>
+          <p:cNvPr id="184" name="Connector 14"/>
           <p:cNvCxnSpPr/>
           <p:nvPr/>
         </p:nvCxnSpPr>
@@ -17653,7 +17365,7 @@
       </p:cxnSp>
       <p:cxnSp>
         <p:nvCxnSpPr>
-          <p:cNvPr id="188" name="Connector 15"/>
+          <p:cNvPr id="185" name="Connector 15"/>
           <p:cNvCxnSpPr/>
           <p:nvPr/>
         </p:nvCxnSpPr>
@@ -17677,7 +17389,7 @@
       </p:cxnSp>
       <p:sp>
         <p:nvSpPr>
-          <p:cNvPr id="189" name="Rounded Rectangle 16"/>
+          <p:cNvPr id="186" name="Rounded Rectangle 16"/>
           <p:cNvSpPr/>
           <p:nvPr/>
         </p:nvSpPr>
@@ -17743,7 +17455,7 @@
       </p:sp>
       <p:sp>
         <p:nvSpPr>
-          <p:cNvPr id="190" name="TextBox 17"/>
+          <p:cNvPr id="187" name="TextBox 17"/>
           <p:cNvSpPr/>
           <p:nvPr/>
         </p:nvSpPr>
@@ -17796,7 +17508,7 @@
       </p:sp>
       <p:sp>
         <p:nvSpPr>
-          <p:cNvPr id="191" name="TextBox 18"/>
+          <p:cNvPr id="188" name="TextBox 18"/>
           <p:cNvSpPr/>
           <p:nvPr/>
         </p:nvSpPr>
@@ -17849,7 +17561,7 @@
       </p:sp>
       <p:sp>
         <p:nvSpPr>
-          <p:cNvPr id="192" name="TextBox 19"/>
+          <p:cNvPr id="189" name="TextBox 19"/>
           <p:cNvSpPr/>
           <p:nvPr/>
         </p:nvSpPr>
@@ -17902,7 +17614,7 @@
       </p:sp>
       <p:sp>
         <p:nvSpPr>
-          <p:cNvPr id="193" name="Rounded Rectangle 20"/>
+          <p:cNvPr id="190" name="Rounded Rectangle 20"/>
           <p:cNvSpPr/>
           <p:nvPr/>
         </p:nvSpPr>
@@ -17968,7 +17680,7 @@
       </p:sp>
       <p:sp>
         <p:nvSpPr>
-          <p:cNvPr id="194" name="TextBox 21"/>
+          <p:cNvPr id="191" name="TextBox 21"/>
           <p:cNvSpPr/>
           <p:nvPr/>
         </p:nvSpPr>
@@ -18021,7 +17733,7 @@
       </p:sp>
       <p:sp>
         <p:nvSpPr>
-          <p:cNvPr id="195" name="TextBox 22"/>
+          <p:cNvPr id="192" name="TextBox 22"/>
           <p:cNvSpPr/>
           <p:nvPr/>
         </p:nvSpPr>
@@ -18074,7 +17786,7 @@
       </p:sp>
       <p:sp>
         <p:nvSpPr>
-          <p:cNvPr id="196" name="TextBox 23"/>
+          <p:cNvPr id="193" name="TextBox 23"/>
           <p:cNvSpPr/>
           <p:nvPr/>
         </p:nvSpPr>
@@ -18127,7 +17839,7 @@
       </p:sp>
       <p:sp>
         <p:nvSpPr>
-          <p:cNvPr id="197" name="Rectangle 24"/>
+          <p:cNvPr id="194" name="Rectangle 24"/>
           <p:cNvSpPr/>
           <p:nvPr/>
         </p:nvSpPr>
@@ -18186,7 +17898,7 @@
       </p:sp>
       <p:sp>
         <p:nvSpPr>
-          <p:cNvPr id="198" name="TextBox 25"/>
+          <p:cNvPr id="195" name="TextBox 25"/>
           <p:cNvSpPr/>
           <p:nvPr/>
         </p:nvSpPr>
@@ -18239,7 +17951,7 @@
       </p:sp>
       <p:sp>
         <p:nvSpPr>
-          <p:cNvPr id="199" name="TextBox 26"/>
+          <p:cNvPr id="196" name="TextBox 26"/>
           <p:cNvSpPr/>
           <p:nvPr/>
         </p:nvSpPr>
@@ -18292,7 +18004,7 @@
       </p:sp>
       <p:sp>
         <p:nvSpPr>
-          <p:cNvPr id="200" name="TextBox 27"/>
+          <p:cNvPr id="197" name="TextBox 27"/>
           <p:cNvSpPr/>
           <p:nvPr/>
         </p:nvSpPr>
@@ -18361,17 +18073,9 @@
   <p:cSld>
     <p:bg>
       <p:bgPr>
-        <a:gradFill rotWithShape="0">
-          <a:gsLst>
-            <a:gs pos="0">
-              <a:srgbClr val="918ef4"/>
-            </a:gs>
-            <a:gs pos="100000">
-              <a:srgbClr val="6f6cd9"/>
-            </a:gs>
-          </a:gsLst>
-          <a:lin ang="2700000"/>
-        </a:gradFill>
+        <a:solidFill>
+          <a:srgbClr val="918ef4"/>
+        </a:solidFill>
       </p:bgPr>
     </p:bg>
     <p:spTree>
@@ -18390,7 +18094,7 @@
       </p:grpSpPr>
       <p:sp>
         <p:nvSpPr>
-          <p:cNvPr id="201" name="TextBox 1"/>
+          <p:cNvPr id="198" name="TextBox 1"/>
           <p:cNvSpPr/>
           <p:nvPr/>
         </p:nvSpPr>
@@ -18443,7 +18147,7 @@
       </p:sp>
       <p:sp>
         <p:nvSpPr>
-          <p:cNvPr id="202" name="TextBox 2"/>
+          <p:cNvPr id="199" name="TextBox 2"/>
           <p:cNvSpPr/>
           <p:nvPr/>
         </p:nvSpPr>
@@ -18496,7 +18200,7 @@
       </p:sp>
       <p:sp>
         <p:nvSpPr>
-          <p:cNvPr id="203" name="TextBox 3"/>
+          <p:cNvPr id="200" name="TextBox 3"/>
           <p:cNvSpPr/>
           <p:nvPr/>
         </p:nvSpPr>
@@ -18549,7 +18253,7 @@
       </p:sp>
       <p:sp>
         <p:nvSpPr>
-          <p:cNvPr id="204" name="TextBox 4"/>
+          <p:cNvPr id="201" name="TextBox 4"/>
           <p:cNvSpPr/>
           <p:nvPr/>
         </p:nvSpPr>
@@ -18602,7 +18306,7 @@
       </p:sp>
       <p:sp>
         <p:nvSpPr>
-          <p:cNvPr id="205" name="Rounded Rectangle 5"/>
+          <p:cNvPr id="202" name="Rounded Rectangle 5"/>
           <p:cNvSpPr/>
           <p:nvPr/>
         </p:nvSpPr>
@@ -18665,7 +18369,7 @@
       </p:sp>
       <p:sp>
         <p:nvSpPr>
-          <p:cNvPr id="206" name="TextBox 6"/>
+          <p:cNvPr id="203" name="TextBox 6"/>
           <p:cNvSpPr/>
           <p:nvPr/>
         </p:nvSpPr>
@@ -18718,7 +18422,7 @@
       </p:sp>
       <p:sp>
         <p:nvSpPr>
-          <p:cNvPr id="207" name="TextBox 7"/>
+          <p:cNvPr id="204" name="TextBox 7"/>
           <p:cNvSpPr/>
           <p:nvPr/>
         </p:nvSpPr>
@@ -18771,7 +18475,7 @@
       </p:sp>
       <p:cxnSp>
         <p:nvCxnSpPr>
-          <p:cNvPr id="208" name="Connector 8"/>
+          <p:cNvPr id="205" name="Connector 8"/>
           <p:cNvCxnSpPr/>
           <p:nvPr/>
         </p:nvCxnSpPr>
@@ -18793,7 +18497,7 @@
       </p:cxnSp>
       <p:cxnSp>
         <p:nvCxnSpPr>
-          <p:cNvPr id="209" name="Connector 9"/>
+          <p:cNvPr id="206" name="Connector 9"/>
           <p:cNvCxnSpPr/>
           <p:nvPr/>
         </p:nvCxnSpPr>
@@ -18815,7 +18519,7 @@
       </p:cxnSp>
       <p:cxnSp>
         <p:nvCxnSpPr>
-          <p:cNvPr id="210" name="Connector 10"/>
+          <p:cNvPr id="207" name="Connector 10"/>
           <p:cNvCxnSpPr/>
           <p:nvPr/>
         </p:nvCxnSpPr>
@@ -18839,7 +18543,7 @@
       </p:cxnSp>
       <p:cxnSp>
         <p:nvCxnSpPr>
-          <p:cNvPr id="211" name="Connector 11"/>
+          <p:cNvPr id="208" name="Connector 11"/>
           <p:cNvCxnSpPr/>
           <p:nvPr/>
         </p:nvCxnSpPr>
@@ -18863,7 +18567,7 @@
       </p:cxnSp>
       <p:sp>
         <p:nvSpPr>
-          <p:cNvPr id="212" name="Rounded Rectangle 12"/>
+          <p:cNvPr id="209" name="Rounded Rectangle 12"/>
           <p:cNvSpPr/>
           <p:nvPr/>
         </p:nvSpPr>
@@ -18929,7 +18633,7 @@
       </p:sp>
       <p:sp>
         <p:nvSpPr>
-          <p:cNvPr id="213" name="TextBox 13"/>
+          <p:cNvPr id="210" name="TextBox 13"/>
           <p:cNvSpPr/>
           <p:nvPr/>
         </p:nvSpPr>
@@ -18982,7 +18686,7 @@
       </p:sp>
       <p:sp>
         <p:nvSpPr>
-          <p:cNvPr id="214" name="TextBox 14"/>
+          <p:cNvPr id="211" name="TextBox 14"/>
           <p:cNvSpPr/>
           <p:nvPr/>
         </p:nvSpPr>
@@ -19035,7 +18739,7 @@
       </p:sp>
       <p:cxnSp>
         <p:nvCxnSpPr>
-          <p:cNvPr id="215" name="Connector 15"/>
+          <p:cNvPr id="212" name="Connector 15"/>
           <p:cNvCxnSpPr/>
           <p:nvPr/>
         </p:nvCxnSpPr>
@@ -19059,7 +18763,7 @@
       </p:cxnSp>
       <p:sp>
         <p:nvSpPr>
-          <p:cNvPr id="216" name="Rounded Rectangle 16"/>
+          <p:cNvPr id="213" name="Rounded Rectangle 16"/>
           <p:cNvSpPr/>
           <p:nvPr/>
         </p:nvSpPr>
@@ -19122,7 +18826,7 @@
       </p:sp>
       <p:sp>
         <p:nvSpPr>
-          <p:cNvPr id="217" name="TextBox 17"/>
+          <p:cNvPr id="214" name="TextBox 17"/>
           <p:cNvSpPr/>
           <p:nvPr/>
         </p:nvSpPr>
@@ -19175,7 +18879,7 @@
       </p:sp>
       <p:sp>
         <p:nvSpPr>
-          <p:cNvPr id="218" name="Rounded Rectangle 18"/>
+          <p:cNvPr id="215" name="Rounded Rectangle 18"/>
           <p:cNvSpPr/>
           <p:nvPr/>
         </p:nvSpPr>
@@ -19241,7 +18945,7 @@
       </p:sp>
       <p:sp>
         <p:nvSpPr>
-          <p:cNvPr id="219" name="TextBox 19"/>
+          <p:cNvPr id="216" name="TextBox 19"/>
           <p:cNvSpPr/>
           <p:nvPr/>
         </p:nvSpPr>
@@ -19294,7 +18998,7 @@
       </p:sp>
       <p:sp>
         <p:nvSpPr>
-          <p:cNvPr id="220" name="TextBox 20"/>
+          <p:cNvPr id="217" name="TextBox 20"/>
           <p:cNvSpPr/>
           <p:nvPr/>
         </p:nvSpPr>
@@ -19347,7 +19051,7 @@
       </p:sp>
       <p:cxnSp>
         <p:nvCxnSpPr>
-          <p:cNvPr id="221" name="Connector 21"/>
+          <p:cNvPr id="218" name="Connector 21"/>
           <p:cNvCxnSpPr/>
           <p:nvPr/>
         </p:nvCxnSpPr>
@@ -19371,7 +19075,7 @@
       </p:cxnSp>
       <p:sp>
         <p:nvSpPr>
-          <p:cNvPr id="222" name="Rounded Rectangle 22"/>
+          <p:cNvPr id="219" name="Rounded Rectangle 22"/>
           <p:cNvSpPr/>
           <p:nvPr/>
         </p:nvSpPr>
@@ -19434,7 +19138,7 @@
       </p:sp>
       <p:sp>
         <p:nvSpPr>
-          <p:cNvPr id="223" name="TextBox 23"/>
+          <p:cNvPr id="220" name="TextBox 23"/>
           <p:cNvSpPr/>
           <p:nvPr/>
         </p:nvSpPr>
@@ -19487,7 +19191,7 @@
       </p:sp>
       <p:sp>
         <p:nvSpPr>
-          <p:cNvPr id="224" name="Rectangle 24"/>
+          <p:cNvPr id="221" name="Rectangle 24"/>
           <p:cNvSpPr/>
           <p:nvPr/>
         </p:nvSpPr>
@@ -19546,7 +19250,7 @@
       </p:sp>
       <p:sp>
         <p:nvSpPr>
-          <p:cNvPr id="225" name="TextBox 25"/>
+          <p:cNvPr id="222" name="TextBox 25"/>
           <p:cNvSpPr/>
           <p:nvPr/>
         </p:nvSpPr>
@@ -19599,7 +19303,7 @@
       </p:sp>
       <p:sp>
         <p:nvSpPr>
-          <p:cNvPr id="226" name="TextBox 26"/>
+          <p:cNvPr id="223" name="TextBox 26"/>
           <p:cNvSpPr/>
           <p:nvPr/>
         </p:nvSpPr>
@@ -19652,7 +19356,7 @@
       </p:sp>
       <p:sp>
         <p:nvSpPr>
-          <p:cNvPr id="227" name="TextBox 27"/>
+          <p:cNvPr id="224" name="TextBox 27"/>
           <p:cNvSpPr/>
           <p:nvPr/>
         </p:nvSpPr>
@@ -19721,17 +19425,9 @@
   <p:cSld>
     <p:bg>
       <p:bgPr>
-        <a:gradFill rotWithShape="0">
-          <a:gsLst>
-            <a:gs pos="0">
-              <a:srgbClr val="918ef4"/>
-            </a:gs>
-            <a:gs pos="100000">
-              <a:srgbClr val="6f6cd9"/>
-            </a:gs>
-          </a:gsLst>
-          <a:lin ang="2700000"/>
-        </a:gradFill>
+        <a:solidFill>
+          <a:srgbClr val="918ef4"/>
+        </a:solidFill>
       </p:bgPr>
     </p:bg>
     <p:spTree>
@@ -19750,7 +19446,7 @@
       </p:grpSpPr>
       <p:sp>
         <p:nvSpPr>
-          <p:cNvPr id="228" name="TextBox 1"/>
+          <p:cNvPr id="225" name="TextBox 1"/>
           <p:cNvSpPr/>
           <p:nvPr/>
         </p:nvSpPr>
@@ -19803,7 +19499,7 @@
       </p:sp>
       <p:sp>
         <p:nvSpPr>
-          <p:cNvPr id="229" name="TextBox 2"/>
+          <p:cNvPr id="226" name="TextBox 2"/>
           <p:cNvSpPr/>
           <p:nvPr/>
         </p:nvSpPr>
@@ -19856,7 +19552,7 @@
       </p:sp>
       <p:sp>
         <p:nvSpPr>
-          <p:cNvPr id="230" name="TextBox 3"/>
+          <p:cNvPr id="227" name="TextBox 3"/>
           <p:cNvSpPr/>
           <p:nvPr/>
         </p:nvSpPr>
@@ -19909,7 +19605,7 @@
       </p:sp>
       <p:sp>
         <p:nvSpPr>
-          <p:cNvPr id="231" name="TextBox 4"/>
+          <p:cNvPr id="228" name="TextBox 4"/>
           <p:cNvSpPr/>
           <p:nvPr/>
         </p:nvSpPr>
@@ -19962,7 +19658,7 @@
       </p:sp>
       <p:sp>
         <p:nvSpPr>
-          <p:cNvPr id="232" name="Rounded Rectangle 5"/>
+          <p:cNvPr id="229" name="Rounded Rectangle 5"/>
           <p:cNvSpPr/>
           <p:nvPr/>
         </p:nvSpPr>
@@ -20025,7 +19721,7 @@
       </p:sp>
       <p:sp>
         <p:nvSpPr>
-          <p:cNvPr id="233" name="TextBox 6"/>
+          <p:cNvPr id="230" name="TextBox 6"/>
           <p:cNvSpPr/>
           <p:nvPr/>
         </p:nvSpPr>
@@ -20078,7 +19774,7 @@
       </p:sp>
       <p:sp>
         <p:nvSpPr>
-          <p:cNvPr id="234" name="Rounded Rectangle 7"/>
+          <p:cNvPr id="231" name="Rounded Rectangle 7"/>
           <p:cNvSpPr/>
           <p:nvPr/>
         </p:nvSpPr>
@@ -20144,7 +19840,7 @@
       </p:sp>
       <p:sp>
         <p:nvSpPr>
-          <p:cNvPr id="235" name="TextBox 8"/>
+          <p:cNvPr id="232" name="TextBox 8"/>
           <p:cNvSpPr/>
           <p:nvPr/>
         </p:nvSpPr>
@@ -20197,7 +19893,7 @@
       </p:sp>
       <p:sp>
         <p:nvSpPr>
-          <p:cNvPr id="236" name="TextBox 9"/>
+          <p:cNvPr id="233" name="TextBox 9"/>
           <p:cNvSpPr/>
           <p:nvPr/>
         </p:nvSpPr>
@@ -20250,7 +19946,7 @@
       </p:sp>
       <p:sp>
         <p:nvSpPr>
-          <p:cNvPr id="237" name="Rounded Rectangle 10"/>
+          <p:cNvPr id="234" name="Rounded Rectangle 10"/>
           <p:cNvSpPr/>
           <p:nvPr/>
         </p:nvSpPr>
@@ -20316,7 +20012,7 @@
       </p:sp>
       <p:sp>
         <p:nvSpPr>
-          <p:cNvPr id="238" name="TextBox 11"/>
+          <p:cNvPr id="235" name="TextBox 11"/>
           <p:cNvSpPr/>
           <p:nvPr/>
         </p:nvSpPr>
@@ -20369,7 +20065,7 @@
       </p:sp>
       <p:sp>
         <p:nvSpPr>
-          <p:cNvPr id="239" name="TextBox 12"/>
+          <p:cNvPr id="236" name="TextBox 12"/>
           <p:cNvSpPr/>
           <p:nvPr/>
         </p:nvSpPr>
@@ -20422,7 +20118,7 @@
       </p:sp>
       <p:sp>
         <p:nvSpPr>
-          <p:cNvPr id="240" name="Rounded Rectangle 13"/>
+          <p:cNvPr id="237" name="Rounded Rectangle 13"/>
           <p:cNvSpPr/>
           <p:nvPr/>
         </p:nvSpPr>
@@ -20488,7 +20184,7 @@
       </p:sp>
       <p:sp>
         <p:nvSpPr>
-          <p:cNvPr id="241" name="TextBox 14"/>
+          <p:cNvPr id="238" name="TextBox 14"/>
           <p:cNvSpPr/>
           <p:nvPr/>
         </p:nvSpPr>
@@ -20541,7 +20237,7 @@
       </p:sp>
       <p:sp>
         <p:nvSpPr>
-          <p:cNvPr id="242" name="TextBox 15"/>
+          <p:cNvPr id="239" name="TextBox 15"/>
           <p:cNvSpPr/>
           <p:nvPr/>
         </p:nvSpPr>
@@ -20594,7 +20290,7 @@
       </p:sp>
       <p:sp>
         <p:nvSpPr>
-          <p:cNvPr id="243" name="Rounded Rectangle 16"/>
+          <p:cNvPr id="240" name="Rounded Rectangle 16"/>
           <p:cNvSpPr/>
           <p:nvPr/>
         </p:nvSpPr>
@@ -20660,7 +20356,7 @@
       </p:sp>
       <p:sp>
         <p:nvSpPr>
-          <p:cNvPr id="244" name="TextBox 17"/>
+          <p:cNvPr id="241" name="TextBox 17"/>
           <p:cNvSpPr/>
           <p:nvPr/>
         </p:nvSpPr>
@@ -20713,7 +20409,7 @@
       </p:sp>
       <p:sp>
         <p:nvSpPr>
-          <p:cNvPr id="245" name="TextBox 18"/>
+          <p:cNvPr id="242" name="TextBox 18"/>
           <p:cNvSpPr/>
           <p:nvPr/>
         </p:nvSpPr>
@@ -20766,7 +20462,7 @@
       </p:sp>
       <p:sp>
         <p:nvSpPr>
-          <p:cNvPr id="246" name="Rounded Rectangle 19"/>
+          <p:cNvPr id="243" name="Rounded Rectangle 19"/>
           <p:cNvSpPr/>
           <p:nvPr/>
         </p:nvSpPr>
@@ -20832,7 +20528,7 @@
       </p:sp>
       <p:sp>
         <p:nvSpPr>
-          <p:cNvPr id="247" name="TextBox 20"/>
+          <p:cNvPr id="244" name="TextBox 20"/>
           <p:cNvSpPr/>
           <p:nvPr/>
         </p:nvSpPr>
@@ -20885,7 +20581,7 @@
       </p:sp>
       <p:sp>
         <p:nvSpPr>
-          <p:cNvPr id="248" name="TextBox 21"/>
+          <p:cNvPr id="245" name="TextBox 21"/>
           <p:cNvSpPr/>
           <p:nvPr/>
         </p:nvSpPr>
@@ -20938,7 +20634,7 @@
       </p:sp>
       <p:sp>
         <p:nvSpPr>
-          <p:cNvPr id="249" name="TextBox 22"/>
+          <p:cNvPr id="246" name="TextBox 22"/>
           <p:cNvSpPr/>
           <p:nvPr/>
         </p:nvSpPr>
@@ -20991,7 +20687,7 @@
       </p:sp>
       <p:sp>
         <p:nvSpPr>
-          <p:cNvPr id="250" name="Rectangle 23"/>
+          <p:cNvPr id="247" name="Rectangle 23"/>
           <p:cNvSpPr/>
           <p:nvPr/>
         </p:nvSpPr>
@@ -21050,7 +20746,7 @@
       </p:sp>
       <p:sp>
         <p:nvSpPr>
-          <p:cNvPr id="251" name="TextBox 24"/>
+          <p:cNvPr id="248" name="TextBox 24"/>
           <p:cNvSpPr/>
           <p:nvPr/>
         </p:nvSpPr>
@@ -21103,7 +20799,7 @@
       </p:sp>
       <p:sp>
         <p:nvSpPr>
-          <p:cNvPr id="252" name="TextBox 25"/>
+          <p:cNvPr id="249" name="TextBox 25"/>
           <p:cNvSpPr/>
           <p:nvPr/>
         </p:nvSpPr>
@@ -21156,7 +20852,7 @@
       </p:sp>
       <p:sp>
         <p:nvSpPr>
-          <p:cNvPr id="253" name="TextBox 26"/>
+          <p:cNvPr id="250" name="TextBox 26"/>
           <p:cNvSpPr/>
           <p:nvPr/>
         </p:nvSpPr>

</xml_diff>